<commit_message>
fix(ops): verify encrypted restore on macOS
</commit_message>
<xml_diff>
--- a/deliverables/ORQESTRA_AI_Final_Viva_Deck.pptx
+++ b/deliverables/ORQESTRA_AI_Final_Viva_Deck.pptx
@@ -2,24 +2,24 @@
 <file path=ppt/presentation.xml><?xml version="1.0" encoding="utf-8"?>
 <p:presentation xmlns:p="http://schemas.openxmlformats.org/presentationml/2006/main">
   <p:sldMasterIdLst>
-    <p:sldMasterId xmlns:r="http://schemas.openxmlformats.org/officeDocument/2006/relationships" id="2147483648" r:id="R30dd217a5b2f42ea"/>
+    <p:sldMasterId xmlns:r="http://schemas.openxmlformats.org/officeDocument/2006/relationships" id="2147483648" r:id="R98d9418242ea4fa3"/>
   </p:sldMasterIdLst>
   <p:notesMasterIdLst>
-    <p:notesMasterId xmlns:r="http://schemas.openxmlformats.org/officeDocument/2006/relationships" r:id="Rbdd2d01fbcca4160"/>
+    <p:notesMasterId xmlns:r="http://schemas.openxmlformats.org/officeDocument/2006/relationships" r:id="R80c7c5fa722b451c"/>
   </p:notesMasterIdLst>
   <p:sldIdLst>
-    <p:sldId xmlns:r="http://schemas.openxmlformats.org/officeDocument/2006/relationships" id="256" r:id="R2238283643904b3e"/>
-    <p:sldId xmlns:r="http://schemas.openxmlformats.org/officeDocument/2006/relationships" id="257" r:id="Rbc842e10246042ba"/>
-    <p:sldId xmlns:r="http://schemas.openxmlformats.org/officeDocument/2006/relationships" id="258" r:id="Raad4f305313e40fe"/>
-    <p:sldId xmlns:r="http://schemas.openxmlformats.org/officeDocument/2006/relationships" id="259" r:id="Rc9d7b37a97704502"/>
-    <p:sldId xmlns:r="http://schemas.openxmlformats.org/officeDocument/2006/relationships" id="260" r:id="R4923eec7ef804659"/>
-    <p:sldId xmlns:r="http://schemas.openxmlformats.org/officeDocument/2006/relationships" id="261" r:id="R3fef3ec7a2594c8a"/>
-    <p:sldId xmlns:r="http://schemas.openxmlformats.org/officeDocument/2006/relationships" id="262" r:id="R42eb67f9982b4a2b"/>
-    <p:sldId xmlns:r="http://schemas.openxmlformats.org/officeDocument/2006/relationships" id="263" r:id="Rdcba521c9d0841a1"/>
-    <p:sldId xmlns:r="http://schemas.openxmlformats.org/officeDocument/2006/relationships" id="264" r:id="R067659a664f44329"/>
-    <p:sldId xmlns:r="http://schemas.openxmlformats.org/officeDocument/2006/relationships" id="265" r:id="R743b2669420245e2"/>
-    <p:sldId xmlns:r="http://schemas.openxmlformats.org/officeDocument/2006/relationships" id="266" r:id="Ra65705a3c70343af"/>
-    <p:sldId xmlns:r="http://schemas.openxmlformats.org/officeDocument/2006/relationships" id="267" r:id="Rc2bea3b320f14438"/>
+    <p:sldId xmlns:r="http://schemas.openxmlformats.org/officeDocument/2006/relationships" id="256" r:id="R8272128ee8bb469d"/>
+    <p:sldId xmlns:r="http://schemas.openxmlformats.org/officeDocument/2006/relationships" id="257" r:id="Rddb431c5f97f4c6d"/>
+    <p:sldId xmlns:r="http://schemas.openxmlformats.org/officeDocument/2006/relationships" id="258" r:id="R6955e3bf1cb74a7f"/>
+    <p:sldId xmlns:r="http://schemas.openxmlformats.org/officeDocument/2006/relationships" id="259" r:id="R67300c6486bf4c25"/>
+    <p:sldId xmlns:r="http://schemas.openxmlformats.org/officeDocument/2006/relationships" id="260" r:id="R18ee314efa5c46f9"/>
+    <p:sldId xmlns:r="http://schemas.openxmlformats.org/officeDocument/2006/relationships" id="261" r:id="R17081b632f3c4e42"/>
+    <p:sldId xmlns:r="http://schemas.openxmlformats.org/officeDocument/2006/relationships" id="262" r:id="R7864844c7f4745ec"/>
+    <p:sldId xmlns:r="http://schemas.openxmlformats.org/officeDocument/2006/relationships" id="263" r:id="R09a9f8c0738c4cd8"/>
+    <p:sldId xmlns:r="http://schemas.openxmlformats.org/officeDocument/2006/relationships" id="264" r:id="R53a03ef5c73d4f5e"/>
+    <p:sldId xmlns:r="http://schemas.openxmlformats.org/officeDocument/2006/relationships" id="265" r:id="R976092b3bbd048b9"/>
+    <p:sldId xmlns:r="http://schemas.openxmlformats.org/officeDocument/2006/relationships" id="266" r:id="R2b6f18257a1f463a"/>
+    <p:sldId xmlns:r="http://schemas.openxmlformats.org/officeDocument/2006/relationships" id="267" r:id="Ra963e1f88b754788"/>
   </p:sldIdLst>
   <p:sldSz cx="12192000" cy="6858000"/>
   <p:notesSz cx="6858000" cy="9144000"/>
@@ -523,7 +523,7 @@
           <a:lstStyle xmlns:a="http://schemas.openxmlformats.org/drawingml/2006/main"/>
           <a:p xmlns:a="http://schemas.openxmlformats.org/drawingml/2006/main">
             <a:r>
-              <a:t>Backup requires GPG and a passphrase file, produces a custom-format PostgreSQL dump, records schema and key row counts, and checksums the dump and manifest. Restore checks archive paths and checksums before creating a new database, applies migrations and compares counts. This code has not run against a live Docker/PostgreSQL host in this workspace. Sources: scripts/backup.sh; scripts/restore.sh; scripts/health_drill.sh.</a:t>
+              <a:t>Backup requires GPG and a passphrase file, produces a custom-format PostgreSQL dump, records schema and key row counts, and checksums the dump and manifest. Restore checks archive paths and checksums before creating a new database, applies migrations and compares counts. The encrypted backup and isolated restore passed against the local Docker/PostgreSQL stack; public hosting and off-host retention remain open. Sources: scripts/backup.sh; scripts/restore.sh; scripts/health_drill.sh; docs/checkpoint16-evidence.md.</a:t>
             </a:r>
           </a:p>
         </p:txBody>
@@ -593,7 +593,7 @@
           <a:lstStyle xmlns:a="http://schemas.openxmlformats.org/drawingml/2006/main"/>
           <a:p xmlns:a="http://schemas.openxmlformats.org/drawingml/2006/main">
             <a:r>
-              <a:t>The latest local run passed 273 tests and skipped two PostgreSQL-only tests. Ruff, formatting, Mypy, and the frontend build pass. No Docker daemon is available here, and no hostname or cloud credentials are configured, so fresh-host TLS deployment and live backup/restore cannot be claimed. Checkpoints 13/14 also retain documented gaps: live PostgreSQL worker kill/restart, browser SSE reconnect and older-workflow search. Sources: README.md; docs/checkpoint16-operations.md; docs/dashboard-observability.md; docs/benchmarks-recovery.md.</a:t>
+              <a:t>The latest backend suite passed 273 tests with two PostgreSQL-only tests skipped; the CI-equivalent PostgreSQL selection passed. Ruff, Mypy, formatting and the frontend build pass. The loopback-only Docker/PostgreSQL stack passed all four demos and the encrypted backup/isolated restore drill. Public DNS/TLS deployment and off-host retention remain unverified because no staging host exists. Checkpoints 13/14 retain documented gaps: live PostgreSQL worker kill/restart, browser SSE reconnect and older-workflow search. Sources: README.md; docs/checkpoint16-operations.md; docs/dashboard-observability.md; docs/benchmarks-recovery.md; docs/checkpoint16-evidence.md.</a:t>
             </a:r>
           </a:p>
         </p:txBody>
@@ -1270,7 +1270,7 @@
           <p:cNvPr id="3" name="Title">
             <a:extLst xmlns:a="http://schemas.openxmlformats.org/drawingml/2006/main">
               <a:ext uri="{FF2B5EF4-FFF2-40B4-BE49-F238E27FC236}">
-                <a16:creationId xmlns:a16="http://schemas.microsoft.com/office/drawing/2014/main" id="{B7BF0A58-520A-4F99-B553-30462FC1E025}"/>
+                <a16:creationId xmlns:a16="http://schemas.microsoft.com/office/drawing/2014/main" id="{0928409D-C680-451D-89C0-D5B6F30920DB}"/>
               </a:ext>
             </a:extLst>
           </p:cNvPr>
@@ -1499,7 +1499,7 @@
           <p:cNvPr id="2" name="Subtitle">
             <a:extLst xmlns:a="http://schemas.openxmlformats.org/drawingml/2006/main">
               <a:ext uri="{FF2B5EF4-FFF2-40B4-BE49-F238E27FC236}">
-                <a16:creationId xmlns:a16="http://schemas.microsoft.com/office/drawing/2014/main" id="{DE6C860E-7F22-4292-9F42-7A2D4D57F953}"/>
+                <a16:creationId xmlns:a16="http://schemas.microsoft.com/office/drawing/2014/main" id="{1E0AF7FC-82FA-47EA-BE0F-38C1920D81C4}"/>
               </a:ext>
             </a:extLst>
           </p:cNvPr>
@@ -1745,7 +1745,7 @@
           <p:cNvPr id="2" name="Section title">
             <a:extLst xmlns:a="http://schemas.openxmlformats.org/drawingml/2006/main">
               <a:ext uri="{FF2B5EF4-FFF2-40B4-BE49-F238E27FC236}">
-                <a16:creationId xmlns:a16="http://schemas.microsoft.com/office/drawing/2014/main" id="{46AED393-B74A-4437-AFB3-2266A921C355}"/>
+                <a16:creationId xmlns:a16="http://schemas.microsoft.com/office/drawing/2014/main" id="{075C13F5-A97D-40C5-906B-5B2236998F52}"/>
               </a:ext>
             </a:extLst>
           </p:cNvPr>
@@ -1991,7 +1991,7 @@
           <p:cNvPr id="3" name="Title">
             <a:extLst xmlns:a="http://schemas.openxmlformats.org/drawingml/2006/main">
               <a:ext uri="{FF2B5EF4-FFF2-40B4-BE49-F238E27FC236}">
-                <a16:creationId xmlns:a16="http://schemas.microsoft.com/office/drawing/2014/main" id="{02C36014-51EB-421E-AC85-7170910B36A9}"/>
+                <a16:creationId xmlns:a16="http://schemas.microsoft.com/office/drawing/2014/main" id="{B99B69A3-842F-408B-A775-6F5E95CC3B0F}"/>
               </a:ext>
             </a:extLst>
           </p:cNvPr>
@@ -2220,7 +2220,7 @@
           <p:cNvPr id="2" name="Body">
             <a:extLst xmlns:a="http://schemas.openxmlformats.org/drawingml/2006/main">
               <a:ext uri="{FF2B5EF4-FFF2-40B4-BE49-F238E27FC236}">
-                <a16:creationId xmlns:a16="http://schemas.microsoft.com/office/drawing/2014/main" id="{D6BC13C5-9EAB-40F0-89ED-91C50F4F44E0}"/>
+                <a16:creationId xmlns:a16="http://schemas.microsoft.com/office/drawing/2014/main" id="{50026CC3-318C-4D65-A324-89C4E638A8CB}"/>
               </a:ext>
             </a:extLst>
           </p:cNvPr>
@@ -2466,7 +2466,7 @@
           <p:cNvPr id="4" name="Title">
             <a:extLst xmlns:a="http://schemas.openxmlformats.org/drawingml/2006/main">
               <a:ext uri="{FF2B5EF4-FFF2-40B4-BE49-F238E27FC236}">
-                <a16:creationId xmlns:a16="http://schemas.microsoft.com/office/drawing/2014/main" id="{D6DF4C62-DD31-44D5-9676-1791721DE8DC}"/>
+                <a16:creationId xmlns:a16="http://schemas.microsoft.com/office/drawing/2014/main" id="{A6356EC2-2E61-4C3F-BAF2-B2F58A6B27AE}"/>
               </a:ext>
             </a:extLst>
           </p:cNvPr>
@@ -2695,7 +2695,7 @@
           <p:cNvPr id="2" name="Left column">
             <a:extLst xmlns:a="http://schemas.openxmlformats.org/drawingml/2006/main">
               <a:ext uri="{FF2B5EF4-FFF2-40B4-BE49-F238E27FC236}">
-                <a16:creationId xmlns:a16="http://schemas.microsoft.com/office/drawing/2014/main" id="{B169AB9D-E8F6-4529-B176-0A74213E3F43}"/>
+                <a16:creationId xmlns:a16="http://schemas.microsoft.com/office/drawing/2014/main" id="{28138F58-B491-48FF-AB7E-B94EB84AFA4C}"/>
               </a:ext>
             </a:extLst>
           </p:cNvPr>
@@ -2924,7 +2924,7 @@
           <p:cNvPr id="3" name="Right column">
             <a:extLst xmlns:a="http://schemas.openxmlformats.org/drawingml/2006/main">
               <a:ext uri="{FF2B5EF4-FFF2-40B4-BE49-F238E27FC236}">
-                <a16:creationId xmlns:a16="http://schemas.microsoft.com/office/drawing/2014/main" id="{11226528-F24C-40BF-AFB3-17427EF38789}"/>
+                <a16:creationId xmlns:a16="http://schemas.microsoft.com/office/drawing/2014/main" id="{D2EABF00-7A0B-4E85-BF7B-ACEEF1A477CE}"/>
               </a:ext>
             </a:extLst>
           </p:cNvPr>
@@ -3170,7 +3170,7 @@
           <p:cNvPr id="3" name="Title">
             <a:extLst xmlns:a="http://schemas.openxmlformats.org/drawingml/2006/main">
               <a:ext uri="{FF2B5EF4-FFF2-40B4-BE49-F238E27FC236}">
-                <a16:creationId xmlns:a16="http://schemas.microsoft.com/office/drawing/2014/main" id="{86933228-9407-48C9-A54F-D73345A86BA7}"/>
+                <a16:creationId xmlns:a16="http://schemas.microsoft.com/office/drawing/2014/main" id="{688BB8E8-0E7D-4860-A3D0-BADE2A3FD9FD}"/>
               </a:ext>
             </a:extLst>
           </p:cNvPr>
@@ -3399,7 +3399,7 @@
           <p:cNvPr id="2" name="Left column">
             <a:extLst xmlns:a="http://schemas.openxmlformats.org/drawingml/2006/main">
               <a:ext uri="{FF2B5EF4-FFF2-40B4-BE49-F238E27FC236}">
-                <a16:creationId xmlns:a16="http://schemas.microsoft.com/office/drawing/2014/main" id="{A7F6E3D2-8C00-4BF2-AA3E-2E2EB1FF33B2}"/>
+                <a16:creationId xmlns:a16="http://schemas.microsoft.com/office/drawing/2014/main" id="{C815FFFA-8C30-4A1A-8140-A3CB6A90B451}"/>
               </a:ext>
             </a:extLst>
           </p:cNvPr>
@@ -3666,12 +3666,12 @@
   </p:cSld>
   <p:clrMap bg1="lt1" tx1="dk1" bg2="lt2" tx2="dk2" accent1="accent1" accent2="accent2" accent3="accent3" accent4="accent4" accent5="accent5" accent6="accent6" hlink="hlink" folHlink="folHlink"/>
   <p:sldLayoutIdLst>
-    <p:sldLayoutId xmlns:r="http://schemas.openxmlformats.org/officeDocument/2006/relationships" id="2147483649" r:id="Rb456b371dc0e475a"/>
-    <p:sldLayoutId xmlns:r="http://schemas.openxmlformats.org/officeDocument/2006/relationships" id="2147483650" r:id="Ra0b97a96f8e2406a"/>
-    <p:sldLayoutId xmlns:r="http://schemas.openxmlformats.org/officeDocument/2006/relationships" id="2147483651" r:id="R47a51bf75efc49ed"/>
-    <p:sldLayoutId xmlns:r="http://schemas.openxmlformats.org/officeDocument/2006/relationships" id="2147483652" r:id="R53b0702b6778408d"/>
-    <p:sldLayoutId xmlns:r="http://schemas.openxmlformats.org/officeDocument/2006/relationships" id="2147483653" r:id="Rbf3ef381822a4def"/>
-    <p:sldLayoutId xmlns:r="http://schemas.openxmlformats.org/officeDocument/2006/relationships" id="2147483654" r:id="R3dbba44fcf97400f"/>
+    <p:sldLayoutId xmlns:r="http://schemas.openxmlformats.org/officeDocument/2006/relationships" id="2147483649" r:id="Reb269018fa5a45ca"/>
+    <p:sldLayoutId xmlns:r="http://schemas.openxmlformats.org/officeDocument/2006/relationships" id="2147483650" r:id="R21c42577984e40ff"/>
+    <p:sldLayoutId xmlns:r="http://schemas.openxmlformats.org/officeDocument/2006/relationships" id="2147483651" r:id="R397394f181af4021"/>
+    <p:sldLayoutId xmlns:r="http://schemas.openxmlformats.org/officeDocument/2006/relationships" id="2147483652" r:id="Rcc58a8ef90d741fc"/>
+    <p:sldLayoutId xmlns:r="http://schemas.openxmlformats.org/officeDocument/2006/relationships" id="2147483653" r:id="R3209d6c93bc1470b"/>
+    <p:sldLayoutId xmlns:r="http://schemas.openxmlformats.org/officeDocument/2006/relationships" id="2147483654" r:id="R1f57cacdeee245c8"/>
   </p:sldLayoutIdLst>
   <p:txStyles>
     <p:titleStyle>
@@ -4222,7 +4222,7 @@
           <p:cNvPr id="6" name="cover-accent">
             <a:extLst xmlns:a="http://schemas.openxmlformats.org/drawingml/2006/main">
               <a:ext uri="{FF2B5EF4-FFF2-40B4-BE49-F238E27FC236}">
-                <a16:creationId xmlns:a16="http://schemas.microsoft.com/office/drawing/2014/main" id="{918597B1-7B2B-4016-918F-994DFC46CAE9}"/>
+                <a16:creationId xmlns:a16="http://schemas.microsoft.com/office/drawing/2014/main" id="{D47232FC-D9C4-438D-9C69-B87B894AB516}"/>
               </a:ext>
             </a:extLst>
           </p:cNvPr>
@@ -4253,7 +4253,7 @@
           <p:cNvPr id="2" name="cover-brand">
             <a:extLst xmlns:a="http://schemas.openxmlformats.org/drawingml/2006/main">
               <a:ext uri="{FF2B5EF4-FFF2-40B4-BE49-F238E27FC236}">
-                <a16:creationId xmlns:a16="http://schemas.microsoft.com/office/drawing/2014/main" id="{706D3842-BB31-4B65-8915-83EA8C078EF6}"/>
+                <a16:creationId xmlns:a16="http://schemas.microsoft.com/office/drawing/2014/main" id="{75D9A975-D824-4D6C-8740-EA770173DF2B}"/>
               </a:ext>
             </a:extLst>
           </p:cNvPr>
@@ -4412,7 +4412,7 @@
           <p:cNvPr id="3" name="cover-title">
             <a:extLst xmlns:a="http://schemas.openxmlformats.org/drawingml/2006/main">
               <a:ext uri="{FF2B5EF4-FFF2-40B4-BE49-F238E27FC236}">
-                <a16:creationId xmlns:a16="http://schemas.microsoft.com/office/drawing/2014/main" id="{DCD82C0E-82E2-4304-B798-BC6C1A1D1A7F}"/>
+                <a16:creationId xmlns:a16="http://schemas.microsoft.com/office/drawing/2014/main" id="{7AB7AE40-C8E8-43E6-BA36-6E7C151CF28E}"/>
               </a:ext>
             </a:extLst>
           </p:cNvPr>
@@ -4594,7 +4594,7 @@
           <p:cNvPr id="4" name="cover-subtitle">
             <a:extLst xmlns:a="http://schemas.openxmlformats.org/drawingml/2006/main">
               <a:ext uri="{FF2B5EF4-FFF2-40B4-BE49-F238E27FC236}">
-                <a16:creationId xmlns:a16="http://schemas.microsoft.com/office/drawing/2014/main" id="{F5BE82D6-3CBF-4B9C-8BDE-1B7F84036022}"/>
+                <a16:creationId xmlns:a16="http://schemas.microsoft.com/office/drawing/2014/main" id="{85B120A6-5D49-4CB3-A7FB-3603BCDE5751}"/>
               </a:ext>
             </a:extLst>
           </p:cNvPr>
@@ -4753,7 +4753,7 @@
           <p:cNvPr id="5" name="cover-date">
             <a:extLst xmlns:a="http://schemas.openxmlformats.org/drawingml/2006/main">
               <a:ext uri="{FF2B5EF4-FFF2-40B4-BE49-F238E27FC236}">
-                <a16:creationId xmlns:a16="http://schemas.microsoft.com/office/drawing/2014/main" id="{01BE744F-7F75-4F0A-9D98-A6DB770DBC00}"/>
+                <a16:creationId xmlns:a16="http://schemas.microsoft.com/office/drawing/2014/main" id="{0B3E7DEE-931C-4E33-81CD-34FD10D0CCA3}"/>
               </a:ext>
             </a:extLst>
           </p:cNvPr>
@@ -4910,7 +4910,7 @@
     </p:spTree>
     <p:extLst>
       <p:ext uri="{BB962C8B-B14F-4D97-AF65-F5344CB8AC3E}">
-        <p14:creationId xmlns:p14="http://schemas.microsoft.com/office/powerpoint/2010/main" val="1949102937"/>
+        <p14:creationId xmlns:p14="http://schemas.microsoft.com/office/powerpoint/2010/main" val="1732191705"/>
       </p:ext>
     </p:extLst>
   </p:cSld>
@@ -4941,7 +4941,7 @@
           <p:cNvPr id="23" name="section-10">
             <a:extLst xmlns:a="http://schemas.openxmlformats.org/drawingml/2006/main">
               <a:ext uri="{FF2B5EF4-FFF2-40B4-BE49-F238E27FC236}">
-                <a16:creationId xmlns:a16="http://schemas.microsoft.com/office/drawing/2014/main" id="{C2F63D19-AD4E-407B-A222-0CA5B432B8AA}"/>
+                <a16:creationId xmlns:a16="http://schemas.microsoft.com/office/drawing/2014/main" id="{9F86C2C4-0BD6-45D5-A46D-F3D2CC202EDF}"/>
               </a:ext>
             </a:extLst>
           </p:cNvPr>
@@ -5100,7 +5100,7 @@
           <p:cNvPr id="2" name="title-10">
             <a:extLst xmlns:a="http://schemas.openxmlformats.org/drawingml/2006/main">
               <a:ext uri="{FF2B5EF4-FFF2-40B4-BE49-F238E27FC236}">
-                <a16:creationId xmlns:a16="http://schemas.microsoft.com/office/drawing/2014/main" id="{5F9C1767-F251-45AB-8C44-29A7AB6BC2BC}"/>
+                <a16:creationId xmlns:a16="http://schemas.microsoft.com/office/drawing/2014/main" id="{48FF9626-CFBE-4734-AFB6-594F1796668C}"/>
               </a:ext>
             </a:extLst>
           </p:cNvPr>
@@ -5259,7 +5259,7 @@
           <p:cNvPr id="3" name="title-rule-10">
             <a:extLst xmlns:a="http://schemas.openxmlformats.org/drawingml/2006/main">
               <a:ext uri="{FF2B5EF4-FFF2-40B4-BE49-F238E27FC236}">
-                <a16:creationId xmlns:a16="http://schemas.microsoft.com/office/drawing/2014/main" id="{7B10C76C-7B5F-488F-AA8A-47BC7359F184}"/>
+                <a16:creationId xmlns:a16="http://schemas.microsoft.com/office/drawing/2014/main" id="{15F3E44D-4E3D-4CDE-9C81-832DC3C6609B}"/>
               </a:ext>
             </a:extLst>
           </p:cNvPr>
@@ -5290,7 +5290,7 @@
           <p:cNvPr id="4" name="footer-rule-10">
             <a:extLst xmlns:a="http://schemas.openxmlformats.org/drawingml/2006/main">
               <a:ext uri="{FF2B5EF4-FFF2-40B4-BE49-F238E27FC236}">
-                <a16:creationId xmlns:a16="http://schemas.microsoft.com/office/drawing/2014/main" id="{B43B2493-FC8B-45F4-B368-88F86CB3855B}"/>
+                <a16:creationId xmlns:a16="http://schemas.microsoft.com/office/drawing/2014/main" id="{9E85CC98-883B-466B-82D0-E1407CBD0FCF}"/>
               </a:ext>
             </a:extLst>
           </p:cNvPr>
@@ -5321,7 +5321,7 @@
           <p:cNvPr id="5" name="footer-10">
             <a:extLst xmlns:a="http://schemas.openxmlformats.org/drawingml/2006/main">
               <a:ext uri="{FF2B5EF4-FFF2-40B4-BE49-F238E27FC236}">
-                <a16:creationId xmlns:a16="http://schemas.microsoft.com/office/drawing/2014/main" id="{A9460314-18BA-4B38-81AD-E5EF1713E43E}"/>
+                <a16:creationId xmlns:a16="http://schemas.microsoft.com/office/drawing/2014/main" id="{01DAF034-843B-4EDC-A6C3-15B993BD5EEE}"/>
               </a:ext>
             </a:extLst>
           </p:cNvPr>
@@ -5480,7 +5480,7 @@
           <p:cNvPr id="6" name="page-10">
             <a:extLst xmlns:a="http://schemas.openxmlformats.org/drawingml/2006/main">
               <a:ext uri="{FF2B5EF4-FFF2-40B4-BE49-F238E27FC236}">
-                <a16:creationId xmlns:a16="http://schemas.microsoft.com/office/drawing/2014/main" id="{A6DA6047-214B-4B1A-8364-C8FA07344DF8}"/>
+                <a16:creationId xmlns:a16="http://schemas.microsoft.com/office/drawing/2014/main" id="{CCDFA3F7-F05C-4826-AE36-A9641E33828A}"/>
               </a:ext>
             </a:extLst>
           </p:cNvPr>
@@ -5639,7 +5639,7 @@
           <p:cNvPr id="7" name="backup-number-0">
             <a:extLst xmlns:a="http://schemas.openxmlformats.org/drawingml/2006/main">
               <a:ext uri="{FF2B5EF4-FFF2-40B4-BE49-F238E27FC236}">
-                <a16:creationId xmlns:a16="http://schemas.microsoft.com/office/drawing/2014/main" id="{91EA56F1-2013-4091-A6F2-0EE8EBD6A531}"/>
+                <a16:creationId xmlns:a16="http://schemas.microsoft.com/office/drawing/2014/main" id="{73443002-0C5C-4F55-802F-A582EADBF874}"/>
               </a:ext>
             </a:extLst>
           </p:cNvPr>
@@ -5798,7 +5798,7 @@
           <p:cNvPr id="8" name="backup-title-0">
             <a:extLst xmlns:a="http://schemas.openxmlformats.org/drawingml/2006/main">
               <a:ext uri="{FF2B5EF4-FFF2-40B4-BE49-F238E27FC236}">
-                <a16:creationId xmlns:a16="http://schemas.microsoft.com/office/drawing/2014/main" id="{409696A0-3958-42CA-B604-05F182977FBA}"/>
+                <a16:creationId xmlns:a16="http://schemas.microsoft.com/office/drawing/2014/main" id="{DEEB4DA9-25BB-4057-94BD-6B60DD40597D}"/>
               </a:ext>
             </a:extLst>
           </p:cNvPr>
@@ -5957,7 +5957,7 @@
           <p:cNvPr id="9" name="backup-sub-0">
             <a:extLst xmlns:a="http://schemas.openxmlformats.org/drawingml/2006/main">
               <a:ext uri="{FF2B5EF4-FFF2-40B4-BE49-F238E27FC236}">
-                <a16:creationId xmlns:a16="http://schemas.microsoft.com/office/drawing/2014/main" id="{E5ABD3E7-F1D5-420B-8DB1-A5F842F5C308}"/>
+                <a16:creationId xmlns:a16="http://schemas.microsoft.com/office/drawing/2014/main" id="{692151AD-75CA-415D-BF2B-6F0162086745}"/>
               </a:ext>
             </a:extLst>
           </p:cNvPr>
@@ -6116,7 +6116,7 @@
           <p:cNvPr id="10" name="backup-line-0">
             <a:extLst xmlns:a="http://schemas.openxmlformats.org/drawingml/2006/main">
               <a:ext uri="{FF2B5EF4-FFF2-40B4-BE49-F238E27FC236}">
-                <a16:creationId xmlns:a16="http://schemas.microsoft.com/office/drawing/2014/main" id="{F2DDE10A-FFD1-4EA3-83CE-79E99CC05260}"/>
+                <a16:creationId xmlns:a16="http://schemas.microsoft.com/office/drawing/2014/main" id="{7183B337-3E0C-4239-804D-84F048DF20C0}"/>
               </a:ext>
             </a:extLst>
           </p:cNvPr>
@@ -6147,7 +6147,7 @@
           <p:cNvPr id="11" name="backup-number-1">
             <a:extLst xmlns:a="http://schemas.openxmlformats.org/drawingml/2006/main">
               <a:ext uri="{FF2B5EF4-FFF2-40B4-BE49-F238E27FC236}">
-                <a16:creationId xmlns:a16="http://schemas.microsoft.com/office/drawing/2014/main" id="{C6C7557B-8D33-4FAE-AC3F-D5617C480D77}"/>
+                <a16:creationId xmlns:a16="http://schemas.microsoft.com/office/drawing/2014/main" id="{CA55F124-8AA7-45B3-98D4-5A7960FA0A59}"/>
               </a:ext>
             </a:extLst>
           </p:cNvPr>
@@ -6306,7 +6306,7 @@
           <p:cNvPr id="12" name="backup-title-1">
             <a:extLst xmlns:a="http://schemas.openxmlformats.org/drawingml/2006/main">
               <a:ext uri="{FF2B5EF4-FFF2-40B4-BE49-F238E27FC236}">
-                <a16:creationId xmlns:a16="http://schemas.microsoft.com/office/drawing/2014/main" id="{D305E26B-A4C8-4F3C-9BD9-D18BDD7515B6}"/>
+                <a16:creationId xmlns:a16="http://schemas.microsoft.com/office/drawing/2014/main" id="{51617668-065B-40A1-A4B5-C3310CC2E766}"/>
               </a:ext>
             </a:extLst>
           </p:cNvPr>
@@ -6465,7 +6465,7 @@
           <p:cNvPr id="13" name="backup-sub-1">
             <a:extLst xmlns:a="http://schemas.openxmlformats.org/drawingml/2006/main">
               <a:ext uri="{FF2B5EF4-FFF2-40B4-BE49-F238E27FC236}">
-                <a16:creationId xmlns:a16="http://schemas.microsoft.com/office/drawing/2014/main" id="{D1EDA779-ECC8-4026-91BA-32BD0ECEFEDF}"/>
+                <a16:creationId xmlns:a16="http://schemas.microsoft.com/office/drawing/2014/main" id="{2F16A9CF-8317-4BE7-9A7B-5F0EA6C39EFB}"/>
               </a:ext>
             </a:extLst>
           </p:cNvPr>
@@ -6624,7 +6624,7 @@
           <p:cNvPr id="14" name="backup-line-1">
             <a:extLst xmlns:a="http://schemas.openxmlformats.org/drawingml/2006/main">
               <a:ext uri="{FF2B5EF4-FFF2-40B4-BE49-F238E27FC236}">
-                <a16:creationId xmlns:a16="http://schemas.microsoft.com/office/drawing/2014/main" id="{3B4429E2-33E2-4F0C-9C80-C3D6D6BBE9F5}"/>
+                <a16:creationId xmlns:a16="http://schemas.microsoft.com/office/drawing/2014/main" id="{E71A2963-DF11-48AB-936F-52D3F8BCF570}"/>
               </a:ext>
             </a:extLst>
           </p:cNvPr>
@@ -6655,7 +6655,7 @@
           <p:cNvPr id="15" name="backup-number-2">
             <a:extLst xmlns:a="http://schemas.openxmlformats.org/drawingml/2006/main">
               <a:ext uri="{FF2B5EF4-FFF2-40B4-BE49-F238E27FC236}">
-                <a16:creationId xmlns:a16="http://schemas.microsoft.com/office/drawing/2014/main" id="{E9722401-034B-4207-9572-F0B45F6FACF1}"/>
+                <a16:creationId xmlns:a16="http://schemas.microsoft.com/office/drawing/2014/main" id="{E5FDB837-AE1A-4B1C-B6BA-D6EEB2D63BEE}"/>
               </a:ext>
             </a:extLst>
           </p:cNvPr>
@@ -6814,7 +6814,7 @@
           <p:cNvPr id="16" name="backup-title-2">
             <a:extLst xmlns:a="http://schemas.openxmlformats.org/drawingml/2006/main">
               <a:ext uri="{FF2B5EF4-FFF2-40B4-BE49-F238E27FC236}">
-                <a16:creationId xmlns:a16="http://schemas.microsoft.com/office/drawing/2014/main" id="{9DE0DB45-1FDB-4C1B-BB71-7E37DF86FCDB}"/>
+                <a16:creationId xmlns:a16="http://schemas.microsoft.com/office/drawing/2014/main" id="{EC0362DF-F0B0-454B-9409-A5F46190AED7}"/>
               </a:ext>
             </a:extLst>
           </p:cNvPr>
@@ -6973,7 +6973,7 @@
           <p:cNvPr id="17" name="backup-sub-2">
             <a:extLst xmlns:a="http://schemas.openxmlformats.org/drawingml/2006/main">
               <a:ext uri="{FF2B5EF4-FFF2-40B4-BE49-F238E27FC236}">
-                <a16:creationId xmlns:a16="http://schemas.microsoft.com/office/drawing/2014/main" id="{772418B8-458B-48EA-AD0C-66CC7D21D3B5}"/>
+                <a16:creationId xmlns:a16="http://schemas.microsoft.com/office/drawing/2014/main" id="{D26A8CF9-47D5-4C5C-8304-E4F5DD7C9E60}"/>
               </a:ext>
             </a:extLst>
           </p:cNvPr>
@@ -7132,7 +7132,7 @@
           <p:cNvPr id="18" name="backup-line-2">
             <a:extLst xmlns:a="http://schemas.openxmlformats.org/drawingml/2006/main">
               <a:ext uri="{FF2B5EF4-FFF2-40B4-BE49-F238E27FC236}">
-                <a16:creationId xmlns:a16="http://schemas.microsoft.com/office/drawing/2014/main" id="{FAE83C16-4BA1-4C0E-BC68-36852A749DD9}"/>
+                <a16:creationId xmlns:a16="http://schemas.microsoft.com/office/drawing/2014/main" id="{972141D5-2822-49DC-81C7-7B8FA93294FE}"/>
               </a:ext>
             </a:extLst>
           </p:cNvPr>
@@ -7163,7 +7163,7 @@
           <p:cNvPr id="19" name="backup-number-3">
             <a:extLst xmlns:a="http://schemas.openxmlformats.org/drawingml/2006/main">
               <a:ext uri="{FF2B5EF4-FFF2-40B4-BE49-F238E27FC236}">
-                <a16:creationId xmlns:a16="http://schemas.microsoft.com/office/drawing/2014/main" id="{8FB22A12-78C6-4E0B-B04B-A08516CA0388}"/>
+                <a16:creationId xmlns:a16="http://schemas.microsoft.com/office/drawing/2014/main" id="{C7DE1C5D-CB5A-4DE9-841A-AF596C46FD82}"/>
               </a:ext>
             </a:extLst>
           </p:cNvPr>
@@ -7322,7 +7322,7 @@
           <p:cNvPr id="20" name="backup-title-3">
             <a:extLst xmlns:a="http://schemas.openxmlformats.org/drawingml/2006/main">
               <a:ext uri="{FF2B5EF4-FFF2-40B4-BE49-F238E27FC236}">
-                <a16:creationId xmlns:a16="http://schemas.microsoft.com/office/drawing/2014/main" id="{0AE1F37B-D454-4594-8DE8-E5650E0A5CFA}"/>
+                <a16:creationId xmlns:a16="http://schemas.microsoft.com/office/drawing/2014/main" id="{75ECD424-A136-4737-A38B-91C1DBB8E752}"/>
               </a:ext>
             </a:extLst>
           </p:cNvPr>
@@ -7481,7 +7481,7 @@
           <p:cNvPr id="21" name="backup-sub-3">
             <a:extLst xmlns:a="http://schemas.openxmlformats.org/drawingml/2006/main">
               <a:ext uri="{FF2B5EF4-FFF2-40B4-BE49-F238E27FC236}">
-                <a16:creationId xmlns:a16="http://schemas.microsoft.com/office/drawing/2014/main" id="{CE4C9F65-2347-4FE1-BE21-8B6BEBEFE1EF}"/>
+                <a16:creationId xmlns:a16="http://schemas.microsoft.com/office/drawing/2014/main" id="{B8FB3980-B2C6-48C7-A455-5F7E3CA3ADA1}"/>
               </a:ext>
             </a:extLst>
           </p:cNvPr>
@@ -7640,7 +7640,7 @@
           <p:cNvPr id="22" name="backup-limit">
             <a:extLst xmlns:a="http://schemas.openxmlformats.org/drawingml/2006/main">
               <a:ext uri="{FF2B5EF4-FFF2-40B4-BE49-F238E27FC236}">
-                <a16:creationId xmlns:a16="http://schemas.microsoft.com/office/drawing/2014/main" id="{A259C275-3DEC-46C8-A844-F2638149E810}"/>
+                <a16:creationId xmlns:a16="http://schemas.microsoft.com/office/drawing/2014/main" id="{83599136-5CFA-4A69-9455-2B40A0AE21A9}"/>
               </a:ext>
             </a:extLst>
           </p:cNvPr>
@@ -7789,7 +7789,7 @@
                 <a:ea typeface="Arial"/>
                 <a:cs typeface="Arial"/>
               </a:rPr>
-              <a:t>An off-host encrypted copy and a successful live restore drill are required for disaster recovery.</a:t>
+              <a:t>Off-host retention and a restore on the staging host are still required for disaster recovery.</a:t>
             </a:r>
           </a:p>
         </p:txBody>
@@ -7797,7 +7797,7 @@
     </p:spTree>
     <p:extLst>
       <p:ext uri="{BB962C8B-B14F-4D97-AF65-F5344CB8AC3E}">
-        <p14:creationId xmlns:p14="http://schemas.microsoft.com/office/powerpoint/2010/main" val="1825364727"/>
+        <p14:creationId xmlns:p14="http://schemas.microsoft.com/office/powerpoint/2010/main" val="1004533477"/>
       </p:ext>
     </p:extLst>
   </p:cSld>
@@ -7828,7 +7828,7 @@
           <p:cNvPr id="13" name="section-11">
             <a:extLst xmlns:a="http://schemas.openxmlformats.org/drawingml/2006/main">
               <a:ext uri="{FF2B5EF4-FFF2-40B4-BE49-F238E27FC236}">
-                <a16:creationId xmlns:a16="http://schemas.microsoft.com/office/drawing/2014/main" id="{E0AF5AF7-A181-4AB0-86B4-DA228FB4D272}"/>
+                <a16:creationId xmlns:a16="http://schemas.microsoft.com/office/drawing/2014/main" id="{BFFBA973-AC61-449C-976B-A80601EC80C9}"/>
               </a:ext>
             </a:extLst>
           </p:cNvPr>
@@ -7987,7 +7987,7 @@
           <p:cNvPr id="2" name="title-11">
             <a:extLst xmlns:a="http://schemas.openxmlformats.org/drawingml/2006/main">
               <a:ext uri="{FF2B5EF4-FFF2-40B4-BE49-F238E27FC236}">
-                <a16:creationId xmlns:a16="http://schemas.microsoft.com/office/drawing/2014/main" id="{97E44862-E07C-464C-A588-77A406630A27}"/>
+                <a16:creationId xmlns:a16="http://schemas.microsoft.com/office/drawing/2014/main" id="{32A8F934-0D5E-4766-9F42-EBB074C675D8}"/>
               </a:ext>
             </a:extLst>
           </p:cNvPr>
@@ -8146,7 +8146,7 @@
           <p:cNvPr id="3" name="title-rule-11">
             <a:extLst xmlns:a="http://schemas.openxmlformats.org/drawingml/2006/main">
               <a:ext uri="{FF2B5EF4-FFF2-40B4-BE49-F238E27FC236}">
-                <a16:creationId xmlns:a16="http://schemas.microsoft.com/office/drawing/2014/main" id="{5D8DB5F1-5673-48B5-A003-F49CB5FED484}"/>
+                <a16:creationId xmlns:a16="http://schemas.microsoft.com/office/drawing/2014/main" id="{1621DEBA-C121-4085-9E67-97778AC4E777}"/>
               </a:ext>
             </a:extLst>
           </p:cNvPr>
@@ -8177,7 +8177,7 @@
           <p:cNvPr id="4" name="footer-rule-11">
             <a:extLst xmlns:a="http://schemas.openxmlformats.org/drawingml/2006/main">
               <a:ext uri="{FF2B5EF4-FFF2-40B4-BE49-F238E27FC236}">
-                <a16:creationId xmlns:a16="http://schemas.microsoft.com/office/drawing/2014/main" id="{BD0D67EA-8BDD-45C6-AA2C-13B19DFCF029}"/>
+                <a16:creationId xmlns:a16="http://schemas.microsoft.com/office/drawing/2014/main" id="{14C5D154-4882-4D81-A167-22ABCAE2626A}"/>
               </a:ext>
             </a:extLst>
           </p:cNvPr>
@@ -8208,7 +8208,7 @@
           <p:cNvPr id="5" name="footer-11">
             <a:extLst xmlns:a="http://schemas.openxmlformats.org/drawingml/2006/main">
               <a:ext uri="{FF2B5EF4-FFF2-40B4-BE49-F238E27FC236}">
-                <a16:creationId xmlns:a16="http://schemas.microsoft.com/office/drawing/2014/main" id="{660BFE73-5045-4B85-8B07-BAF79BD022FB}"/>
+                <a16:creationId xmlns:a16="http://schemas.microsoft.com/office/drawing/2014/main" id="{8F8AB60B-82CA-4FD9-AF52-BCC92DDD5E82}"/>
               </a:ext>
             </a:extLst>
           </p:cNvPr>
@@ -8367,7 +8367,7 @@
           <p:cNvPr id="6" name="page-11">
             <a:extLst xmlns:a="http://schemas.openxmlformats.org/drawingml/2006/main">
               <a:ext uri="{FF2B5EF4-FFF2-40B4-BE49-F238E27FC236}">
-                <a16:creationId xmlns:a16="http://schemas.microsoft.com/office/drawing/2014/main" id="{B82D2748-2BEB-4E53-8394-FECC89BFFCE5}"/>
+                <a16:creationId xmlns:a16="http://schemas.microsoft.com/office/drawing/2014/main" id="{9CCAC458-D869-411E-8367-E0ADF55C2BFC}"/>
               </a:ext>
             </a:extLst>
           </p:cNvPr>
@@ -8526,7 +8526,7 @@
           <p:cNvPr id="7" name="status-local">
             <a:extLst xmlns:a="http://schemas.openxmlformats.org/drawingml/2006/main">
               <a:ext uri="{FF2B5EF4-FFF2-40B4-BE49-F238E27FC236}">
-                <a16:creationId xmlns:a16="http://schemas.microsoft.com/office/drawing/2014/main" id="{70387C4F-A062-4A63-AE64-F814958426B4}"/>
+                <a16:creationId xmlns:a16="http://schemas.microsoft.com/office/drawing/2014/main" id="{8C5CFC6F-930E-4D85-88B9-7BEFDFB56428}"/>
               </a:ext>
             </a:extLst>
           </p:cNvPr>
@@ -8685,7 +8685,7 @@
           <p:cNvPr id="8" name="status-local-body">
             <a:extLst xmlns:a="http://schemas.openxmlformats.org/drawingml/2006/main">
               <a:ext uri="{FF2B5EF4-FFF2-40B4-BE49-F238E27FC236}">
-                <a16:creationId xmlns:a16="http://schemas.microsoft.com/office/drawing/2014/main" id="{08524843-65DD-455F-8928-73FCAE7A4888}"/>
+                <a16:creationId xmlns:a16="http://schemas.microsoft.com/office/drawing/2014/main" id="{85DC7EBF-B79F-4924-A22F-57F75C0C9B16}"/>
               </a:ext>
             </a:extLst>
           </p:cNvPr>
@@ -8903,6 +8903,29 @@
                 <a:ea typeface="Arial"/>
                 <a:cs typeface="Arial"/>
               </a:rPr>
+              <a:t>Four demos + backup/restore</a:t>
+            </a:r>
+          </a:p>
+          <a:p xmlns:a="http://schemas.openxmlformats.org/drawingml/2006/main">
+            <a:pPr algn="l">
+              <a:defRPr sz="1725" b="0">
+                <a:solidFill>
+                  <a:srgbClr val="A8B7BC"/>
+                </a:solidFill>
+                <a:latin typeface="Arial"/>
+                <a:ea typeface="Arial"/>
+                <a:cs typeface="Arial"/>
+              </a:defRPr>
+            </a:pPr>
+            <a:r>
+              <a:rPr sz="1725" b="0">
+                <a:solidFill>
+                  <a:srgbClr val="A8B7BC"/>
+                </a:solidFill>
+                <a:latin typeface="Arial"/>
+                <a:ea typeface="Arial"/>
+                <a:cs typeface="Arial"/>
+              </a:rPr>
               <a:t>Compose overlay syntax</a:t>
             </a:r>
           </a:p>
@@ -8913,7 +8936,7 @@
           <p:cNvPr id="9" name="status-divider">
             <a:extLst xmlns:a="http://schemas.openxmlformats.org/drawingml/2006/main">
               <a:ext uri="{FF2B5EF4-FFF2-40B4-BE49-F238E27FC236}">
-                <a16:creationId xmlns:a16="http://schemas.microsoft.com/office/drawing/2014/main" id="{D850CDCD-C3A0-4BEE-B465-6B609C8CDD9D}"/>
+                <a16:creationId xmlns:a16="http://schemas.microsoft.com/office/drawing/2014/main" id="{2BBA3F8E-AA9B-456D-8D90-AD083031AFC6}"/>
               </a:ext>
             </a:extLst>
           </p:cNvPr>
@@ -8944,7 +8967,7 @@
           <p:cNvPr id="10" name="status-open">
             <a:extLst xmlns:a="http://schemas.openxmlformats.org/drawingml/2006/main">
               <a:ext uri="{FF2B5EF4-FFF2-40B4-BE49-F238E27FC236}">
-                <a16:creationId xmlns:a16="http://schemas.microsoft.com/office/drawing/2014/main" id="{24D81F30-2149-4D0B-855E-F222A25867E2}"/>
+                <a16:creationId xmlns:a16="http://schemas.microsoft.com/office/drawing/2014/main" id="{6E58D402-5C7E-44B6-B0CA-93140A9868C9}"/>
               </a:ext>
             </a:extLst>
           </p:cNvPr>
@@ -9103,7 +9126,7 @@
           <p:cNvPr id="11" name="status-open-body">
             <a:extLst xmlns:a="http://schemas.openxmlformats.org/drawingml/2006/main">
               <a:ext uri="{FF2B5EF4-FFF2-40B4-BE49-F238E27FC236}">
-                <a16:creationId xmlns:a16="http://schemas.microsoft.com/office/drawing/2014/main" id="{24721F4A-0066-4D12-8E5A-23AE72EE5D12}"/>
+                <a16:creationId xmlns:a16="http://schemas.microsoft.com/office/drawing/2014/main" id="{45A67752-8AFE-4759-BC44-8325DE1BDDF6}"/>
               </a:ext>
             </a:extLst>
           </p:cNvPr>
@@ -9252,7 +9275,7 @@
                 <a:ea typeface="Arial"/>
                 <a:cs typeface="Arial"/>
               </a:rPr>
-              <a:t>Fresh VPS + DNS + TLS certificate</a:t>
+              <a:t>Fresh VPS + public DNS/TLS</a:t>
             </a:r>
           </a:p>
           <a:p xmlns:a="http://schemas.openxmlformats.org/drawingml/2006/main">
@@ -9275,7 +9298,7 @@
                 <a:ea typeface="Arial"/>
                 <a:cs typeface="Arial"/>
               </a:rPr>
-              <a:t>Encrypted PostgreSQL backup and restore</a:t>
+              <a:t>Off-host backup retention</a:t>
             </a:r>
           </a:p>
           <a:p xmlns:a="http://schemas.openxmlformats.org/drawingml/2006/main">
@@ -9298,7 +9321,7 @@
                 <a:ea typeface="Arial"/>
                 <a:cs typeface="Arial"/>
               </a:rPr>
-              <a:t>All three core demos on the host</a:t>
+              <a:t>Core demos on the host</a:t>
             </a:r>
           </a:p>
           <a:p xmlns:a="http://schemas.openxmlformats.org/drawingml/2006/main">
@@ -9331,7 +9354,7 @@
           <p:cNvPr id="12" name="status-hold">
             <a:extLst xmlns:a="http://schemas.openxmlformats.org/drawingml/2006/main">
               <a:ext uri="{FF2B5EF4-FFF2-40B4-BE49-F238E27FC236}">
-                <a16:creationId xmlns:a16="http://schemas.microsoft.com/office/drawing/2014/main" id="{6242F8C4-DEE3-4767-8C8D-789EBF192BBD}"/>
+                <a16:creationId xmlns:a16="http://schemas.microsoft.com/office/drawing/2014/main" id="{BAEA8968-809D-432A-A134-1FC38CA9AAD1}"/>
               </a:ext>
             </a:extLst>
           </p:cNvPr>
@@ -9488,7 +9511,7 @@
     </p:spTree>
     <p:extLst>
       <p:ext uri="{BB962C8B-B14F-4D97-AF65-F5344CB8AC3E}">
-        <p14:creationId xmlns:p14="http://schemas.microsoft.com/office/powerpoint/2010/main" val="1615074651"/>
+        <p14:creationId xmlns:p14="http://schemas.microsoft.com/office/powerpoint/2010/main" val="1144282350"/>
       </p:ext>
     </p:extLst>
   </p:cSld>
@@ -9519,7 +9542,7 @@
           <p:cNvPr id="16" name="section-12">
             <a:extLst xmlns:a="http://schemas.openxmlformats.org/drawingml/2006/main">
               <a:ext uri="{FF2B5EF4-FFF2-40B4-BE49-F238E27FC236}">
-                <a16:creationId xmlns:a16="http://schemas.microsoft.com/office/drawing/2014/main" id="{68677438-B057-4B66-AFE1-2020DFB3602C}"/>
+                <a16:creationId xmlns:a16="http://schemas.microsoft.com/office/drawing/2014/main" id="{8432F8AF-9039-4775-B1D0-711763DE2860}"/>
               </a:ext>
             </a:extLst>
           </p:cNvPr>
@@ -9678,7 +9701,7 @@
           <p:cNvPr id="2" name="title-12">
             <a:extLst xmlns:a="http://schemas.openxmlformats.org/drawingml/2006/main">
               <a:ext uri="{FF2B5EF4-FFF2-40B4-BE49-F238E27FC236}">
-                <a16:creationId xmlns:a16="http://schemas.microsoft.com/office/drawing/2014/main" id="{79C5C57E-BA18-4F79-B9EC-F24F9200F4C1}"/>
+                <a16:creationId xmlns:a16="http://schemas.microsoft.com/office/drawing/2014/main" id="{1DF9CD19-8D7C-4B88-836F-7C1B6DF2D52A}"/>
               </a:ext>
             </a:extLst>
           </p:cNvPr>
@@ -9837,7 +9860,7 @@
           <p:cNvPr id="3" name="title-rule-12">
             <a:extLst xmlns:a="http://schemas.openxmlformats.org/drawingml/2006/main">
               <a:ext uri="{FF2B5EF4-FFF2-40B4-BE49-F238E27FC236}">
-                <a16:creationId xmlns:a16="http://schemas.microsoft.com/office/drawing/2014/main" id="{F3D74997-9EDF-4E24-B941-A53ED51AB25C}"/>
+                <a16:creationId xmlns:a16="http://schemas.microsoft.com/office/drawing/2014/main" id="{B5BF0E2A-4D99-48B3-AC6B-61DDA74D1BAC}"/>
               </a:ext>
             </a:extLst>
           </p:cNvPr>
@@ -9868,7 +9891,7 @@
           <p:cNvPr id="4" name="footer-rule-12">
             <a:extLst xmlns:a="http://schemas.openxmlformats.org/drawingml/2006/main">
               <a:ext uri="{FF2B5EF4-FFF2-40B4-BE49-F238E27FC236}">
-                <a16:creationId xmlns:a16="http://schemas.microsoft.com/office/drawing/2014/main" id="{52F83996-BEB2-4EB6-B5CF-4BAC0F0600C3}"/>
+                <a16:creationId xmlns:a16="http://schemas.microsoft.com/office/drawing/2014/main" id="{A2CDCFD3-ECD0-458B-9453-8738ECDC8A75}"/>
               </a:ext>
             </a:extLst>
           </p:cNvPr>
@@ -9899,7 +9922,7 @@
           <p:cNvPr id="5" name="footer-12">
             <a:extLst xmlns:a="http://schemas.openxmlformats.org/drawingml/2006/main">
               <a:ext uri="{FF2B5EF4-FFF2-40B4-BE49-F238E27FC236}">
-                <a16:creationId xmlns:a16="http://schemas.microsoft.com/office/drawing/2014/main" id="{18FBAB4E-8A5A-4006-89BF-AE822153F494}"/>
+                <a16:creationId xmlns:a16="http://schemas.microsoft.com/office/drawing/2014/main" id="{369E8494-4585-4665-A843-A2FBF56FFC2F}"/>
               </a:ext>
             </a:extLst>
           </p:cNvPr>
@@ -10058,7 +10081,7 @@
           <p:cNvPr id="6" name="page-12">
             <a:extLst xmlns:a="http://schemas.openxmlformats.org/drawingml/2006/main">
               <a:ext uri="{FF2B5EF4-FFF2-40B4-BE49-F238E27FC236}">
-                <a16:creationId xmlns:a16="http://schemas.microsoft.com/office/drawing/2014/main" id="{A6460DD3-D946-4E1E-9AF5-2333E4486A76}"/>
+                <a16:creationId xmlns:a16="http://schemas.microsoft.com/office/drawing/2014/main" id="{C9D01250-7F60-45A8-A64D-881FB3B05981}"/>
               </a:ext>
             </a:extLst>
           </p:cNvPr>
@@ -10217,7 +10240,7 @@
           <p:cNvPr id="7" name="viva-a-marker">
             <a:extLst xmlns:a="http://schemas.openxmlformats.org/drawingml/2006/main">
               <a:ext uri="{FF2B5EF4-FFF2-40B4-BE49-F238E27FC236}">
-                <a16:creationId xmlns:a16="http://schemas.microsoft.com/office/drawing/2014/main" id="{82B17688-8EF3-4B85-B8B9-7803B047C5BE}"/>
+                <a16:creationId xmlns:a16="http://schemas.microsoft.com/office/drawing/2014/main" id="{C9996CB9-3531-4F0F-A630-D9474CFADD4A}"/>
               </a:ext>
             </a:extLst>
           </p:cNvPr>
@@ -10248,7 +10271,7 @@
           <p:cNvPr id="8" name="viva-a-heading">
             <a:extLst xmlns:a="http://schemas.openxmlformats.org/drawingml/2006/main">
               <a:ext uri="{FF2B5EF4-FFF2-40B4-BE49-F238E27FC236}">
-                <a16:creationId xmlns:a16="http://schemas.microsoft.com/office/drawing/2014/main" id="{219FA525-5888-4DDF-B908-FD92943C39B4}"/>
+                <a16:creationId xmlns:a16="http://schemas.microsoft.com/office/drawing/2014/main" id="{3B7C6739-1AF9-48E7-A9A4-D7FE3F1FB901}"/>
               </a:ext>
             </a:extLst>
           </p:cNvPr>
@@ -10407,7 +10430,7 @@
           <p:cNvPr id="9" name="viva-a-body">
             <a:extLst xmlns:a="http://schemas.openxmlformats.org/drawingml/2006/main">
               <a:ext uri="{FF2B5EF4-FFF2-40B4-BE49-F238E27FC236}">
-                <a16:creationId xmlns:a16="http://schemas.microsoft.com/office/drawing/2014/main" id="{6B9B13E5-96C5-4B5F-91B7-48EA0C63F2F0}"/>
+                <a16:creationId xmlns:a16="http://schemas.microsoft.com/office/drawing/2014/main" id="{C9B932F5-6571-4B6B-8487-6DC1B5BD7248}"/>
               </a:ext>
             </a:extLst>
           </p:cNvPr>
@@ -10566,7 +10589,7 @@
           <p:cNvPr id="10" name="viva-b-marker">
             <a:extLst xmlns:a="http://schemas.openxmlformats.org/drawingml/2006/main">
               <a:ext uri="{FF2B5EF4-FFF2-40B4-BE49-F238E27FC236}">
-                <a16:creationId xmlns:a16="http://schemas.microsoft.com/office/drawing/2014/main" id="{DB2C05BB-0CD9-4636-9853-8CEB6AE0969B}"/>
+                <a16:creationId xmlns:a16="http://schemas.microsoft.com/office/drawing/2014/main" id="{05F6AF49-F66D-4D1B-B3A9-25F6AEEEE406}"/>
               </a:ext>
             </a:extLst>
           </p:cNvPr>
@@ -10597,7 +10620,7 @@
           <p:cNvPr id="11" name="viva-b-heading">
             <a:extLst xmlns:a="http://schemas.openxmlformats.org/drawingml/2006/main">
               <a:ext uri="{FF2B5EF4-FFF2-40B4-BE49-F238E27FC236}">
-                <a16:creationId xmlns:a16="http://schemas.microsoft.com/office/drawing/2014/main" id="{DC184BB0-9FCE-47AD-9C37-E9141814D224}"/>
+                <a16:creationId xmlns:a16="http://schemas.microsoft.com/office/drawing/2014/main" id="{AE4ECA7F-BE2C-485E-A0F2-ADCFB5364EE3}"/>
               </a:ext>
             </a:extLst>
           </p:cNvPr>
@@ -10756,7 +10779,7 @@
           <p:cNvPr id="12" name="viva-b-body">
             <a:extLst xmlns:a="http://schemas.openxmlformats.org/drawingml/2006/main">
               <a:ext uri="{FF2B5EF4-FFF2-40B4-BE49-F238E27FC236}">
-                <a16:creationId xmlns:a16="http://schemas.microsoft.com/office/drawing/2014/main" id="{A4D3F479-F014-49B2-B3CD-3F0F40C9FABC}"/>
+                <a16:creationId xmlns:a16="http://schemas.microsoft.com/office/drawing/2014/main" id="{D72E791B-1A2E-4ADA-95DE-F7827F2E3AD5}"/>
               </a:ext>
             </a:extLst>
           </p:cNvPr>
@@ -10915,7 +10938,7 @@
           <p:cNvPr id="13" name="viva-c-marker">
             <a:extLst xmlns:a="http://schemas.openxmlformats.org/drawingml/2006/main">
               <a:ext uri="{FF2B5EF4-FFF2-40B4-BE49-F238E27FC236}">
-                <a16:creationId xmlns:a16="http://schemas.microsoft.com/office/drawing/2014/main" id="{5B9DC3C5-8E88-4EBD-87C8-1354408EF63D}"/>
+                <a16:creationId xmlns:a16="http://schemas.microsoft.com/office/drawing/2014/main" id="{E6B458C6-68FB-41D4-947E-C9BAA0FC711C}"/>
               </a:ext>
             </a:extLst>
           </p:cNvPr>
@@ -10946,7 +10969,7 @@
           <p:cNvPr id="14" name="viva-c-heading">
             <a:extLst xmlns:a="http://schemas.openxmlformats.org/drawingml/2006/main">
               <a:ext uri="{FF2B5EF4-FFF2-40B4-BE49-F238E27FC236}">
-                <a16:creationId xmlns:a16="http://schemas.microsoft.com/office/drawing/2014/main" id="{1C90FA63-5350-42BD-941E-44B608934147}"/>
+                <a16:creationId xmlns:a16="http://schemas.microsoft.com/office/drawing/2014/main" id="{034EC41D-1267-49BA-A0FF-C85D9171B8D7}"/>
               </a:ext>
             </a:extLst>
           </p:cNvPr>
@@ -11105,7 +11128,7 @@
           <p:cNvPr id="15" name="viva-c-body">
             <a:extLst xmlns:a="http://schemas.openxmlformats.org/drawingml/2006/main">
               <a:ext uri="{FF2B5EF4-FFF2-40B4-BE49-F238E27FC236}">
-                <a16:creationId xmlns:a16="http://schemas.microsoft.com/office/drawing/2014/main" id="{7C94BF0A-6543-4D7B-A79B-4E26FCFC74B9}"/>
+                <a16:creationId xmlns:a16="http://schemas.microsoft.com/office/drawing/2014/main" id="{BBF1E74F-A325-4C27-8406-1854412257D3}"/>
               </a:ext>
             </a:extLst>
           </p:cNvPr>
@@ -11262,7 +11285,7 @@
     </p:spTree>
     <p:extLst>
       <p:ext uri="{BB962C8B-B14F-4D97-AF65-F5344CB8AC3E}">
-        <p14:creationId xmlns:p14="http://schemas.microsoft.com/office/powerpoint/2010/main" val="120190743"/>
+        <p14:creationId xmlns:p14="http://schemas.microsoft.com/office/powerpoint/2010/main" val="430349772"/>
       </p:ext>
     </p:extLst>
   </p:cSld>
@@ -11293,7 +11316,7 @@
           <p:cNvPr id="16" name="section-2">
             <a:extLst xmlns:a="http://schemas.openxmlformats.org/drawingml/2006/main">
               <a:ext uri="{FF2B5EF4-FFF2-40B4-BE49-F238E27FC236}">
-                <a16:creationId xmlns:a16="http://schemas.microsoft.com/office/drawing/2014/main" id="{98456E8F-E291-4775-B4D4-567DCB9FDCF8}"/>
+                <a16:creationId xmlns:a16="http://schemas.microsoft.com/office/drawing/2014/main" id="{081B832E-0011-4E1F-9D52-036E14DB1ABE}"/>
               </a:ext>
             </a:extLst>
           </p:cNvPr>
@@ -11452,7 +11475,7 @@
           <p:cNvPr id="2" name="title-2">
             <a:extLst xmlns:a="http://schemas.openxmlformats.org/drawingml/2006/main">
               <a:ext uri="{FF2B5EF4-FFF2-40B4-BE49-F238E27FC236}">
-                <a16:creationId xmlns:a16="http://schemas.microsoft.com/office/drawing/2014/main" id="{03D7F4EB-0FC4-4A16-ACD6-54F36839B9F9}"/>
+                <a16:creationId xmlns:a16="http://schemas.microsoft.com/office/drawing/2014/main" id="{04A01DE2-720C-4C6C-8F5E-418864CBA359}"/>
               </a:ext>
             </a:extLst>
           </p:cNvPr>
@@ -11611,7 +11634,7 @@
           <p:cNvPr id="3" name="title-rule-2">
             <a:extLst xmlns:a="http://schemas.openxmlformats.org/drawingml/2006/main">
               <a:ext uri="{FF2B5EF4-FFF2-40B4-BE49-F238E27FC236}">
-                <a16:creationId xmlns:a16="http://schemas.microsoft.com/office/drawing/2014/main" id="{3014F0E4-CBB8-4D23-9464-27691D653C68}"/>
+                <a16:creationId xmlns:a16="http://schemas.microsoft.com/office/drawing/2014/main" id="{7D2DF370-189C-4735-B9B4-748B091C07A0}"/>
               </a:ext>
             </a:extLst>
           </p:cNvPr>
@@ -11642,7 +11665,7 @@
           <p:cNvPr id="4" name="footer-rule-2">
             <a:extLst xmlns:a="http://schemas.openxmlformats.org/drawingml/2006/main">
               <a:ext uri="{FF2B5EF4-FFF2-40B4-BE49-F238E27FC236}">
-                <a16:creationId xmlns:a16="http://schemas.microsoft.com/office/drawing/2014/main" id="{8042C4EA-BF23-4DAA-9954-339152DC3524}"/>
+                <a16:creationId xmlns:a16="http://schemas.microsoft.com/office/drawing/2014/main" id="{12B4314C-8F9D-472E-ADDD-60367B19A0A0}"/>
               </a:ext>
             </a:extLst>
           </p:cNvPr>
@@ -11673,7 +11696,7 @@
           <p:cNvPr id="5" name="footer-2">
             <a:extLst xmlns:a="http://schemas.openxmlformats.org/drawingml/2006/main">
               <a:ext uri="{FF2B5EF4-FFF2-40B4-BE49-F238E27FC236}">
-                <a16:creationId xmlns:a16="http://schemas.microsoft.com/office/drawing/2014/main" id="{30BB7453-AB17-496A-9111-085FFB65EF76}"/>
+                <a16:creationId xmlns:a16="http://schemas.microsoft.com/office/drawing/2014/main" id="{1CB4DD9A-5DAD-4944-B2E0-1EE3559EDF0A}"/>
               </a:ext>
             </a:extLst>
           </p:cNvPr>
@@ -11832,7 +11855,7 @@
           <p:cNvPr id="6" name="page-2">
             <a:extLst xmlns:a="http://schemas.openxmlformats.org/drawingml/2006/main">
               <a:ext uri="{FF2B5EF4-FFF2-40B4-BE49-F238E27FC236}">
-                <a16:creationId xmlns:a16="http://schemas.microsoft.com/office/drawing/2014/main" id="{4701CE09-73D0-4340-BBFE-8CC354206A2C}"/>
+                <a16:creationId xmlns:a16="http://schemas.microsoft.com/office/drawing/2014/main" id="{9034205A-5CC8-4ACF-8271-7ED46735C1EA}"/>
               </a:ext>
             </a:extLst>
           </p:cNvPr>
@@ -11991,7 +12014,7 @@
           <p:cNvPr id="7" name="problem-a-marker">
             <a:extLst xmlns:a="http://schemas.openxmlformats.org/drawingml/2006/main">
               <a:ext uri="{FF2B5EF4-FFF2-40B4-BE49-F238E27FC236}">
-                <a16:creationId xmlns:a16="http://schemas.microsoft.com/office/drawing/2014/main" id="{71C7676A-FFC8-46BD-BAB9-B91A7C2E5E3E}"/>
+                <a16:creationId xmlns:a16="http://schemas.microsoft.com/office/drawing/2014/main" id="{971C76DD-D10B-423C-A9EE-24B40D6EF627}"/>
               </a:ext>
             </a:extLst>
           </p:cNvPr>
@@ -12022,7 +12045,7 @@
           <p:cNvPr id="8" name="problem-a-heading">
             <a:extLst xmlns:a="http://schemas.openxmlformats.org/drawingml/2006/main">
               <a:ext uri="{FF2B5EF4-FFF2-40B4-BE49-F238E27FC236}">
-                <a16:creationId xmlns:a16="http://schemas.microsoft.com/office/drawing/2014/main" id="{8DEC2C09-C1B6-4FFF-9C2D-04AF5091FE84}"/>
+                <a16:creationId xmlns:a16="http://schemas.microsoft.com/office/drawing/2014/main" id="{17E52DD5-1E41-4654-B76E-DC23BBFADDAC}"/>
               </a:ext>
             </a:extLst>
           </p:cNvPr>
@@ -12181,7 +12204,7 @@
           <p:cNvPr id="9" name="problem-a-body">
             <a:extLst xmlns:a="http://schemas.openxmlformats.org/drawingml/2006/main">
               <a:ext uri="{FF2B5EF4-FFF2-40B4-BE49-F238E27FC236}">
-                <a16:creationId xmlns:a16="http://schemas.microsoft.com/office/drawing/2014/main" id="{90F44302-8527-421F-B996-2AB3D2CF6296}"/>
+                <a16:creationId xmlns:a16="http://schemas.microsoft.com/office/drawing/2014/main" id="{13A2653E-FBAE-4CA6-A9E8-AD145FC59B35}"/>
               </a:ext>
             </a:extLst>
           </p:cNvPr>
@@ -12340,7 +12363,7 @@
           <p:cNvPr id="10" name="problem-b-marker">
             <a:extLst xmlns:a="http://schemas.openxmlformats.org/drawingml/2006/main">
               <a:ext uri="{FF2B5EF4-FFF2-40B4-BE49-F238E27FC236}">
-                <a16:creationId xmlns:a16="http://schemas.microsoft.com/office/drawing/2014/main" id="{1CCDE83E-02D1-4BBA-8C47-BB917D388517}"/>
+                <a16:creationId xmlns:a16="http://schemas.microsoft.com/office/drawing/2014/main" id="{33D5D690-1F07-46CC-8C68-B5288F468259}"/>
               </a:ext>
             </a:extLst>
           </p:cNvPr>
@@ -12371,7 +12394,7 @@
           <p:cNvPr id="11" name="problem-b-heading">
             <a:extLst xmlns:a="http://schemas.openxmlformats.org/drawingml/2006/main">
               <a:ext uri="{FF2B5EF4-FFF2-40B4-BE49-F238E27FC236}">
-                <a16:creationId xmlns:a16="http://schemas.microsoft.com/office/drawing/2014/main" id="{B70AB842-C2D4-4AD9-B89B-85CAFE2ABC1A}"/>
+                <a16:creationId xmlns:a16="http://schemas.microsoft.com/office/drawing/2014/main" id="{40B1E81C-801F-4E1D-A5AC-259B1DE905E8}"/>
               </a:ext>
             </a:extLst>
           </p:cNvPr>
@@ -12530,7 +12553,7 @@
           <p:cNvPr id="12" name="problem-b-body">
             <a:extLst xmlns:a="http://schemas.openxmlformats.org/drawingml/2006/main">
               <a:ext uri="{FF2B5EF4-FFF2-40B4-BE49-F238E27FC236}">
-                <a16:creationId xmlns:a16="http://schemas.microsoft.com/office/drawing/2014/main" id="{0CF8C9A0-3065-48FD-9E7C-89E9966EB8C1}"/>
+                <a16:creationId xmlns:a16="http://schemas.microsoft.com/office/drawing/2014/main" id="{E7017630-40C3-4FB8-A0F7-74E105DE4716}"/>
               </a:ext>
             </a:extLst>
           </p:cNvPr>
@@ -12689,7 +12712,7 @@
           <p:cNvPr id="13" name="problem-c-marker">
             <a:extLst xmlns:a="http://schemas.openxmlformats.org/drawingml/2006/main">
               <a:ext uri="{FF2B5EF4-FFF2-40B4-BE49-F238E27FC236}">
-                <a16:creationId xmlns:a16="http://schemas.microsoft.com/office/drawing/2014/main" id="{9AF181A1-EC3F-456A-8626-1EF78C2C371D}"/>
+                <a16:creationId xmlns:a16="http://schemas.microsoft.com/office/drawing/2014/main" id="{B333708A-DECF-496D-A73C-481CD77931A2}"/>
               </a:ext>
             </a:extLst>
           </p:cNvPr>
@@ -12720,7 +12743,7 @@
           <p:cNvPr id="14" name="problem-c-heading">
             <a:extLst xmlns:a="http://schemas.openxmlformats.org/drawingml/2006/main">
               <a:ext uri="{FF2B5EF4-FFF2-40B4-BE49-F238E27FC236}">
-                <a16:creationId xmlns:a16="http://schemas.microsoft.com/office/drawing/2014/main" id="{F579558E-5B72-4AA9-8D74-0032A43F7401}"/>
+                <a16:creationId xmlns:a16="http://schemas.microsoft.com/office/drawing/2014/main" id="{807CB4FA-832D-4FC9-B953-32486B41862A}"/>
               </a:ext>
             </a:extLst>
           </p:cNvPr>
@@ -12879,7 +12902,7 @@
           <p:cNvPr id="15" name="problem-c-body">
             <a:extLst xmlns:a="http://schemas.openxmlformats.org/drawingml/2006/main">
               <a:ext uri="{FF2B5EF4-FFF2-40B4-BE49-F238E27FC236}">
-                <a16:creationId xmlns:a16="http://schemas.microsoft.com/office/drawing/2014/main" id="{F9DAEFCB-5DD2-4B17-8C65-DA4CC9077FAD}"/>
+                <a16:creationId xmlns:a16="http://schemas.microsoft.com/office/drawing/2014/main" id="{3E9893C7-F952-467F-B00C-1F7C17F2E81A}"/>
               </a:ext>
             </a:extLst>
           </p:cNvPr>
@@ -13036,7 +13059,7 @@
     </p:spTree>
     <p:extLst>
       <p:ext uri="{BB962C8B-B14F-4D97-AF65-F5344CB8AC3E}">
-        <p14:creationId xmlns:p14="http://schemas.microsoft.com/office/powerpoint/2010/main" val="1351819908"/>
+        <p14:creationId xmlns:p14="http://schemas.microsoft.com/office/powerpoint/2010/main" val="1180247847"/>
       </p:ext>
     </p:extLst>
   </p:cSld>
@@ -13067,7 +13090,7 @@
           <p:cNvPr id="23" name="">
             <a:extLst xmlns:a="http://schemas.openxmlformats.org/drawingml/2006/main">
               <a:ext uri="{FF2B5EF4-FFF2-40B4-BE49-F238E27FC236}">
-                <a16:creationId xmlns:a16="http://schemas.microsoft.com/office/drawing/2014/main" id="{FD84307B-B2BD-4642-AE9E-474B354BCDB1}"/>
+                <a16:creationId xmlns:a16="http://schemas.microsoft.com/office/drawing/2014/main" id="{68A4E30E-1792-4206-A273-EBD3E8320B14}"/>
               </a:ext>
             </a:extLst>
           </p:cNvPr>
@@ -13098,7 +13121,7 @@
           <p:cNvPr id="22" name="">
             <a:extLst xmlns:a="http://schemas.openxmlformats.org/drawingml/2006/main">
               <a:ext uri="{FF2B5EF4-FFF2-40B4-BE49-F238E27FC236}">
-                <a16:creationId xmlns:a16="http://schemas.microsoft.com/office/drawing/2014/main" id="{E720104F-C7F6-42F0-9564-4540718EB839}"/>
+                <a16:creationId xmlns:a16="http://schemas.microsoft.com/office/drawing/2014/main" id="{1230ED2D-4AF5-4658-A2DE-DF9E71BA5F2C}"/>
               </a:ext>
             </a:extLst>
           </p:cNvPr>
@@ -13131,7 +13154,7 @@
           <p:cNvPr id="21" name="">
             <a:extLst xmlns:a="http://schemas.openxmlformats.org/drawingml/2006/main">
               <a:ext uri="{FF2B5EF4-FFF2-40B4-BE49-F238E27FC236}">
-                <a16:creationId xmlns:a16="http://schemas.microsoft.com/office/drawing/2014/main" id="{9B4356E0-DE68-43DB-B06F-70153DD7DF91}"/>
+                <a16:creationId xmlns:a16="http://schemas.microsoft.com/office/drawing/2014/main" id="{E68E1B9A-C652-44CA-B9EA-4356FADD519A}"/>
               </a:ext>
             </a:extLst>
           </p:cNvPr>
@@ -13164,7 +13187,7 @@
           <p:cNvPr id="20" name="">
             <a:extLst xmlns:a="http://schemas.openxmlformats.org/drawingml/2006/main">
               <a:ext uri="{FF2B5EF4-FFF2-40B4-BE49-F238E27FC236}">
-                <a16:creationId xmlns:a16="http://schemas.microsoft.com/office/drawing/2014/main" id="{2CE0A629-5D8D-4B4A-BB06-BA746BFE229C}"/>
+                <a16:creationId xmlns:a16="http://schemas.microsoft.com/office/drawing/2014/main" id="{59278776-F509-4190-A1C6-F5400CB6E0F3}"/>
               </a:ext>
             </a:extLst>
           </p:cNvPr>
@@ -13197,7 +13220,7 @@
           <p:cNvPr id="19" name="">
             <a:extLst xmlns:a="http://schemas.openxmlformats.org/drawingml/2006/main">
               <a:ext uri="{FF2B5EF4-FFF2-40B4-BE49-F238E27FC236}">
-                <a16:creationId xmlns:a16="http://schemas.microsoft.com/office/drawing/2014/main" id="{F7D2F33B-D0D2-4C7C-8620-7A2060ACA857}"/>
+                <a16:creationId xmlns:a16="http://schemas.microsoft.com/office/drawing/2014/main" id="{B910F957-D2D9-4F18-88AE-2B2CE91B5D6B}"/>
               </a:ext>
             </a:extLst>
           </p:cNvPr>
@@ -13228,7 +13251,7 @@
           <p:cNvPr id="26" name="section-3">
             <a:extLst xmlns:a="http://schemas.openxmlformats.org/drawingml/2006/main">
               <a:ext uri="{FF2B5EF4-FFF2-40B4-BE49-F238E27FC236}">
-                <a16:creationId xmlns:a16="http://schemas.microsoft.com/office/drawing/2014/main" id="{3476DF65-C374-4455-B995-F82458F05DA6}"/>
+                <a16:creationId xmlns:a16="http://schemas.microsoft.com/office/drawing/2014/main" id="{BACCCD5D-8282-4B76-AA35-4FC53A81403C}"/>
               </a:ext>
             </a:extLst>
           </p:cNvPr>
@@ -13387,7 +13410,7 @@
           <p:cNvPr id="2" name="title-3">
             <a:extLst xmlns:a="http://schemas.openxmlformats.org/drawingml/2006/main">
               <a:ext uri="{FF2B5EF4-FFF2-40B4-BE49-F238E27FC236}">
-                <a16:creationId xmlns:a16="http://schemas.microsoft.com/office/drawing/2014/main" id="{6FAE3628-C7BF-494A-9489-D861DFC44F39}"/>
+                <a16:creationId xmlns:a16="http://schemas.microsoft.com/office/drawing/2014/main" id="{1077C85B-5472-424C-AD7B-F3A9A327A3DE}"/>
               </a:ext>
             </a:extLst>
           </p:cNvPr>
@@ -13546,7 +13569,7 @@
           <p:cNvPr id="3" name="title-rule-3">
             <a:extLst xmlns:a="http://schemas.openxmlformats.org/drawingml/2006/main">
               <a:ext uri="{FF2B5EF4-FFF2-40B4-BE49-F238E27FC236}">
-                <a16:creationId xmlns:a16="http://schemas.microsoft.com/office/drawing/2014/main" id="{8A38891A-4764-4FB8-9717-9F7A65585802}"/>
+                <a16:creationId xmlns:a16="http://schemas.microsoft.com/office/drawing/2014/main" id="{2C2DC897-7AE2-401D-A625-872E8C3BBC8D}"/>
               </a:ext>
             </a:extLst>
           </p:cNvPr>
@@ -13577,7 +13600,7 @@
           <p:cNvPr id="4" name="footer-rule-3">
             <a:extLst xmlns:a="http://schemas.openxmlformats.org/drawingml/2006/main">
               <a:ext uri="{FF2B5EF4-FFF2-40B4-BE49-F238E27FC236}">
-                <a16:creationId xmlns:a16="http://schemas.microsoft.com/office/drawing/2014/main" id="{7D93DAE0-561D-4CB9-A9D3-1ABCAC05C441}"/>
+                <a16:creationId xmlns:a16="http://schemas.microsoft.com/office/drawing/2014/main" id="{277A02CE-1847-4DB4-B511-F478BEC83112}"/>
               </a:ext>
             </a:extLst>
           </p:cNvPr>
@@ -13608,7 +13631,7 @@
           <p:cNvPr id="5" name="footer-3">
             <a:extLst xmlns:a="http://schemas.openxmlformats.org/drawingml/2006/main">
               <a:ext uri="{FF2B5EF4-FFF2-40B4-BE49-F238E27FC236}">
-                <a16:creationId xmlns:a16="http://schemas.microsoft.com/office/drawing/2014/main" id="{089468E1-322E-45F3-9FBE-2BD34E5179B3}"/>
+                <a16:creationId xmlns:a16="http://schemas.microsoft.com/office/drawing/2014/main" id="{1BA2B06D-FEFE-4917-B9B1-4AAD6DFC7BFB}"/>
               </a:ext>
             </a:extLst>
           </p:cNvPr>
@@ -13767,7 +13790,7 @@
           <p:cNvPr id="6" name="page-3">
             <a:extLst xmlns:a="http://schemas.openxmlformats.org/drawingml/2006/main">
               <a:ext uri="{FF2B5EF4-FFF2-40B4-BE49-F238E27FC236}">
-                <a16:creationId xmlns:a16="http://schemas.microsoft.com/office/drawing/2014/main" id="{A1709AC7-7269-437D-A68F-5F47CCFCAAA3}"/>
+                <a16:creationId xmlns:a16="http://schemas.microsoft.com/office/drawing/2014/main" id="{61E84E70-9823-47D0-9F9B-11AA6375E602}"/>
               </a:ext>
             </a:extLst>
           </p:cNvPr>
@@ -13926,7 +13949,7 @@
           <p:cNvPr id="7" name="browser">
             <a:extLst xmlns:a="http://schemas.openxmlformats.org/drawingml/2006/main">
               <a:ext uri="{FF2B5EF4-FFF2-40B4-BE49-F238E27FC236}">
-                <a16:creationId xmlns:a16="http://schemas.microsoft.com/office/drawing/2014/main" id="{21A93A90-E25D-4989-BF63-EEE13585CECA}"/>
+                <a16:creationId xmlns:a16="http://schemas.microsoft.com/office/drawing/2014/main" id="{7AB17635-BA92-4C6F-B582-B5C8A0752D6E}"/>
               </a:ext>
             </a:extLst>
           </p:cNvPr>
@@ -13959,7 +13982,7 @@
           <p:cNvPr id="8" name="browser-label">
             <a:extLst xmlns:a="http://schemas.openxmlformats.org/drawingml/2006/main">
               <a:ext uri="{FF2B5EF4-FFF2-40B4-BE49-F238E27FC236}">
-                <a16:creationId xmlns:a16="http://schemas.microsoft.com/office/drawing/2014/main" id="{2FB32742-D519-48A7-9E10-1FF4CC315B0F}"/>
+                <a16:creationId xmlns:a16="http://schemas.microsoft.com/office/drawing/2014/main" id="{540A9D59-B664-45E3-813E-E83E75C8E92A}"/>
               </a:ext>
             </a:extLst>
           </p:cNvPr>
@@ -14141,7 +14164,7 @@
           <p:cNvPr id="9" name="caddy">
             <a:extLst xmlns:a="http://schemas.openxmlformats.org/drawingml/2006/main">
               <a:ext uri="{FF2B5EF4-FFF2-40B4-BE49-F238E27FC236}">
-                <a16:creationId xmlns:a16="http://schemas.microsoft.com/office/drawing/2014/main" id="{815D2726-8CEC-47A6-8447-2502F3058CB1}"/>
+                <a16:creationId xmlns:a16="http://schemas.microsoft.com/office/drawing/2014/main" id="{83BA16BD-7605-4DAB-8A9D-58C11EFC8F88}"/>
               </a:ext>
             </a:extLst>
           </p:cNvPr>
@@ -14174,7 +14197,7 @@
           <p:cNvPr id="10" name="caddy-label">
             <a:extLst xmlns:a="http://schemas.openxmlformats.org/drawingml/2006/main">
               <a:ext uri="{FF2B5EF4-FFF2-40B4-BE49-F238E27FC236}">
-                <a16:creationId xmlns:a16="http://schemas.microsoft.com/office/drawing/2014/main" id="{A2537897-2C68-4F13-A373-F8499C62747D}"/>
+                <a16:creationId xmlns:a16="http://schemas.microsoft.com/office/drawing/2014/main" id="{B8A9BC82-960F-437A-B424-2F2E75F2C676}"/>
               </a:ext>
             </a:extLst>
           </p:cNvPr>
@@ -14356,7 +14379,7 @@
           <p:cNvPr id="11" name="frontend">
             <a:extLst xmlns:a="http://schemas.openxmlformats.org/drawingml/2006/main">
               <a:ext uri="{FF2B5EF4-FFF2-40B4-BE49-F238E27FC236}">
-                <a16:creationId xmlns:a16="http://schemas.microsoft.com/office/drawing/2014/main" id="{8F4C7AF9-5E09-480C-9A65-6BD8ABC2FD75}"/>
+                <a16:creationId xmlns:a16="http://schemas.microsoft.com/office/drawing/2014/main" id="{E4BCA1AA-C130-402D-AF42-E34D314A0F56}"/>
               </a:ext>
             </a:extLst>
           </p:cNvPr>
@@ -14389,7 +14412,7 @@
           <p:cNvPr id="12" name="frontend-label">
             <a:extLst xmlns:a="http://schemas.openxmlformats.org/drawingml/2006/main">
               <a:ext uri="{FF2B5EF4-FFF2-40B4-BE49-F238E27FC236}">
-                <a16:creationId xmlns:a16="http://schemas.microsoft.com/office/drawing/2014/main" id="{EA3616AA-F10B-41AF-BDC6-C58A0E6CFF47}"/>
+                <a16:creationId xmlns:a16="http://schemas.microsoft.com/office/drawing/2014/main" id="{AF18A5CE-B712-4ED6-87BE-69B03A2C9084}"/>
               </a:ext>
             </a:extLst>
           </p:cNvPr>
@@ -14571,7 +14594,7 @@
           <p:cNvPr id="13" name="api">
             <a:extLst xmlns:a="http://schemas.openxmlformats.org/drawingml/2006/main">
               <a:ext uri="{FF2B5EF4-FFF2-40B4-BE49-F238E27FC236}">
-                <a16:creationId xmlns:a16="http://schemas.microsoft.com/office/drawing/2014/main" id="{5D5C8AAB-0D23-4F87-BB59-9B800EEF3701}"/>
+                <a16:creationId xmlns:a16="http://schemas.microsoft.com/office/drawing/2014/main" id="{48D82CB6-D780-411E-9349-8C423E0A8093}"/>
               </a:ext>
             </a:extLst>
           </p:cNvPr>
@@ -14604,7 +14627,7 @@
           <p:cNvPr id="14" name="api-label">
             <a:extLst xmlns:a="http://schemas.openxmlformats.org/drawingml/2006/main">
               <a:ext uri="{FF2B5EF4-FFF2-40B4-BE49-F238E27FC236}">
-                <a16:creationId xmlns:a16="http://schemas.microsoft.com/office/drawing/2014/main" id="{B9D854EA-B063-4188-8495-4D0E697B6AF7}"/>
+                <a16:creationId xmlns:a16="http://schemas.microsoft.com/office/drawing/2014/main" id="{ECE55640-7DFA-4F0B-8827-DCE6EB22DECB}"/>
               </a:ext>
             </a:extLst>
           </p:cNvPr>
@@ -14786,7 +14809,7 @@
           <p:cNvPr id="15" name="postgres">
             <a:extLst xmlns:a="http://schemas.openxmlformats.org/drawingml/2006/main">
               <a:ext uri="{FF2B5EF4-FFF2-40B4-BE49-F238E27FC236}">
-                <a16:creationId xmlns:a16="http://schemas.microsoft.com/office/drawing/2014/main" id="{F807DCBB-EA9E-469A-BD67-A163F21F8B82}"/>
+                <a16:creationId xmlns:a16="http://schemas.microsoft.com/office/drawing/2014/main" id="{FF4CAA44-36A8-4980-A31A-18DDA3C9B912}"/>
               </a:ext>
             </a:extLst>
           </p:cNvPr>
@@ -14819,7 +14842,7 @@
           <p:cNvPr id="16" name="postgres-label">
             <a:extLst xmlns:a="http://schemas.openxmlformats.org/drawingml/2006/main">
               <a:ext uri="{FF2B5EF4-FFF2-40B4-BE49-F238E27FC236}">
-                <a16:creationId xmlns:a16="http://schemas.microsoft.com/office/drawing/2014/main" id="{FAAC5D5E-3927-4789-9182-FA00220D4811}"/>
+                <a16:creationId xmlns:a16="http://schemas.microsoft.com/office/drawing/2014/main" id="{87E04EFD-9CDB-48E9-A190-023E1CDA9A0A}"/>
               </a:ext>
             </a:extLst>
           </p:cNvPr>
@@ -15001,7 +15024,7 @@
           <p:cNvPr id="17" name="worker">
             <a:extLst xmlns:a="http://schemas.openxmlformats.org/drawingml/2006/main">
               <a:ext uri="{FF2B5EF4-FFF2-40B4-BE49-F238E27FC236}">
-                <a16:creationId xmlns:a16="http://schemas.microsoft.com/office/drawing/2014/main" id="{59C6A2AC-45CF-4E97-BCA0-36F671F5C219}"/>
+                <a16:creationId xmlns:a16="http://schemas.microsoft.com/office/drawing/2014/main" id="{70C6EAE6-E0A9-4B52-B61A-CF8101FBD8C8}"/>
               </a:ext>
             </a:extLst>
           </p:cNvPr>
@@ -15034,7 +15057,7 @@
           <p:cNvPr id="18" name="worker-label">
             <a:extLst xmlns:a="http://schemas.openxmlformats.org/drawingml/2006/main">
               <a:ext uri="{FF2B5EF4-FFF2-40B4-BE49-F238E27FC236}">
-                <a16:creationId xmlns:a16="http://schemas.microsoft.com/office/drawing/2014/main" id="{9A6EE616-2FA8-4115-8799-F2D288C39A09}"/>
+                <a16:creationId xmlns:a16="http://schemas.microsoft.com/office/drawing/2014/main" id="{F9EB764A-0E01-4AEA-A1DB-8D1976C332C8}"/>
               </a:ext>
             </a:extLst>
           </p:cNvPr>
@@ -15216,7 +15239,7 @@
           <p:cNvPr id="24" name="redis-note">
             <a:extLst xmlns:a="http://schemas.openxmlformats.org/drawingml/2006/main">
               <a:ext uri="{FF2B5EF4-FFF2-40B4-BE49-F238E27FC236}">
-                <a16:creationId xmlns:a16="http://schemas.microsoft.com/office/drawing/2014/main" id="{6A0A1CA3-EAE8-481D-BAE9-BE143FFD9D85}"/>
+                <a16:creationId xmlns:a16="http://schemas.microsoft.com/office/drawing/2014/main" id="{787269C2-F867-4FE3-A252-BB898AAD8EA2}"/>
               </a:ext>
             </a:extLst>
           </p:cNvPr>
@@ -15375,7 +15398,7 @@
           <p:cNvPr id="25" name="security-note">
             <a:extLst xmlns:a="http://schemas.openxmlformats.org/drawingml/2006/main">
               <a:ext uri="{FF2B5EF4-FFF2-40B4-BE49-F238E27FC236}">
-                <a16:creationId xmlns:a16="http://schemas.microsoft.com/office/drawing/2014/main" id="{BBEC9CBE-0758-4386-85C8-814ED322D854}"/>
+                <a16:creationId xmlns:a16="http://schemas.microsoft.com/office/drawing/2014/main" id="{7D750CB1-E310-4F50-8EE1-6781FBFE6346}"/>
               </a:ext>
             </a:extLst>
           </p:cNvPr>
@@ -15532,7 +15555,7 @@
     </p:spTree>
     <p:extLst>
       <p:ext uri="{BB962C8B-B14F-4D97-AF65-F5344CB8AC3E}">
-        <p14:creationId xmlns:p14="http://schemas.microsoft.com/office/powerpoint/2010/main" val="1774745242"/>
+        <p14:creationId xmlns:p14="http://schemas.microsoft.com/office/powerpoint/2010/main" val="1319209694"/>
       </p:ext>
     </p:extLst>
   </p:cSld>
@@ -15563,7 +15586,7 @@
           <p:cNvPr id="33" name="section-4">
             <a:extLst xmlns:a="http://schemas.openxmlformats.org/drawingml/2006/main">
               <a:ext uri="{FF2B5EF4-FFF2-40B4-BE49-F238E27FC236}">
-                <a16:creationId xmlns:a16="http://schemas.microsoft.com/office/drawing/2014/main" id="{0324D09B-FDC7-48B5-AA09-F358AAA37950}"/>
+                <a16:creationId xmlns:a16="http://schemas.microsoft.com/office/drawing/2014/main" id="{08EAD795-5613-4E8B-BC97-9FBA240D0AA7}"/>
               </a:ext>
             </a:extLst>
           </p:cNvPr>
@@ -15722,7 +15745,7 @@
           <p:cNvPr id="2" name="title-4">
             <a:extLst xmlns:a="http://schemas.openxmlformats.org/drawingml/2006/main">
               <a:ext uri="{FF2B5EF4-FFF2-40B4-BE49-F238E27FC236}">
-                <a16:creationId xmlns:a16="http://schemas.microsoft.com/office/drawing/2014/main" id="{C14D56BE-7AE5-4599-A02D-23DC345ABAF3}"/>
+                <a16:creationId xmlns:a16="http://schemas.microsoft.com/office/drawing/2014/main" id="{B4E75CBC-51E5-430E-943E-57AB33FB3ED3}"/>
               </a:ext>
             </a:extLst>
           </p:cNvPr>
@@ -15881,7 +15904,7 @@
           <p:cNvPr id="3" name="title-rule-4">
             <a:extLst xmlns:a="http://schemas.openxmlformats.org/drawingml/2006/main">
               <a:ext uri="{FF2B5EF4-FFF2-40B4-BE49-F238E27FC236}">
-                <a16:creationId xmlns:a16="http://schemas.microsoft.com/office/drawing/2014/main" id="{4547FB29-2C00-46A1-BEC1-BD245150F96C}"/>
+                <a16:creationId xmlns:a16="http://schemas.microsoft.com/office/drawing/2014/main" id="{AB5CE11E-99DC-4A84-A523-2E97467705D2}"/>
               </a:ext>
             </a:extLst>
           </p:cNvPr>
@@ -15912,7 +15935,7 @@
           <p:cNvPr id="4" name="footer-rule-4">
             <a:extLst xmlns:a="http://schemas.openxmlformats.org/drawingml/2006/main">
               <a:ext uri="{FF2B5EF4-FFF2-40B4-BE49-F238E27FC236}">
-                <a16:creationId xmlns:a16="http://schemas.microsoft.com/office/drawing/2014/main" id="{089E9DDC-011E-459B-B682-6C85AEABE97D}"/>
+                <a16:creationId xmlns:a16="http://schemas.microsoft.com/office/drawing/2014/main" id="{03F0DF94-2A18-4998-BAA7-80B7FEF90183}"/>
               </a:ext>
             </a:extLst>
           </p:cNvPr>
@@ -15943,7 +15966,7 @@
           <p:cNvPr id="5" name="footer-4">
             <a:extLst xmlns:a="http://schemas.openxmlformats.org/drawingml/2006/main">
               <a:ext uri="{FF2B5EF4-FFF2-40B4-BE49-F238E27FC236}">
-                <a16:creationId xmlns:a16="http://schemas.microsoft.com/office/drawing/2014/main" id="{C31EED90-AA74-4FB4-AC2D-E1C49AB564D2}"/>
+                <a16:creationId xmlns:a16="http://schemas.microsoft.com/office/drawing/2014/main" id="{3603FF64-FE22-4E01-AD01-11DAE4E2195E}"/>
               </a:ext>
             </a:extLst>
           </p:cNvPr>
@@ -16102,7 +16125,7 @@
           <p:cNvPr id="6" name="page-4">
             <a:extLst xmlns:a="http://schemas.openxmlformats.org/drawingml/2006/main">
               <a:ext uri="{FF2B5EF4-FFF2-40B4-BE49-F238E27FC236}">
-                <a16:creationId xmlns:a16="http://schemas.microsoft.com/office/drawing/2014/main" id="{1D6BA89C-E3D3-4015-AD21-49FD9F492C54}"/>
+                <a16:creationId xmlns:a16="http://schemas.microsoft.com/office/drawing/2014/main" id="{2E0DA498-EBE2-4F81-858B-ACF9FB86C3D3}"/>
               </a:ext>
             </a:extLst>
           </p:cNvPr>
@@ -16261,7 +16284,7 @@
           <p:cNvPr id="7" name="lifecycle-line">
             <a:extLst xmlns:a="http://schemas.openxmlformats.org/drawingml/2006/main">
               <a:ext uri="{FF2B5EF4-FFF2-40B4-BE49-F238E27FC236}">
-                <a16:creationId xmlns:a16="http://schemas.microsoft.com/office/drawing/2014/main" id="{F38A2241-9CBB-45F0-9B1B-00C432498B1E}"/>
+                <a16:creationId xmlns:a16="http://schemas.microsoft.com/office/drawing/2014/main" id="{C65E9AAF-773B-4811-AB73-685039D7826D}"/>
               </a:ext>
             </a:extLst>
           </p:cNvPr>
@@ -16292,7 +16315,7 @@
           <p:cNvPr id="8" name="step-dot-0">
             <a:extLst xmlns:a="http://schemas.openxmlformats.org/drawingml/2006/main">
               <a:ext uri="{FF2B5EF4-FFF2-40B4-BE49-F238E27FC236}">
-                <a16:creationId xmlns:a16="http://schemas.microsoft.com/office/drawing/2014/main" id="{C8ABEBA6-70E7-4905-B7DC-629A69233E4E}"/>
+                <a16:creationId xmlns:a16="http://schemas.microsoft.com/office/drawing/2014/main" id="{1D3F6A25-8E6E-4CB5-B94C-2388D8916995}"/>
               </a:ext>
             </a:extLst>
           </p:cNvPr>
@@ -16323,7 +16346,7 @@
           <p:cNvPr id="9" name="step-number-0">
             <a:extLst xmlns:a="http://schemas.openxmlformats.org/drawingml/2006/main">
               <a:ext uri="{FF2B5EF4-FFF2-40B4-BE49-F238E27FC236}">
-                <a16:creationId xmlns:a16="http://schemas.microsoft.com/office/drawing/2014/main" id="{1F28B06B-00A4-4FC7-90F4-28D9D96951AB}"/>
+                <a16:creationId xmlns:a16="http://schemas.microsoft.com/office/drawing/2014/main" id="{E61D78C8-A37C-4118-A2F3-40338A8E64FA}"/>
               </a:ext>
             </a:extLst>
           </p:cNvPr>
@@ -16482,7 +16505,7 @@
           <p:cNvPr id="10" name="step-heading-0">
             <a:extLst xmlns:a="http://schemas.openxmlformats.org/drawingml/2006/main">
               <a:ext uri="{FF2B5EF4-FFF2-40B4-BE49-F238E27FC236}">
-                <a16:creationId xmlns:a16="http://schemas.microsoft.com/office/drawing/2014/main" id="{32B8AA24-7870-49A7-9BEB-5DB7B11BEA79}"/>
+                <a16:creationId xmlns:a16="http://schemas.microsoft.com/office/drawing/2014/main" id="{AA467E8E-B7E2-47B8-9F36-8C80A55F97AC}"/>
               </a:ext>
             </a:extLst>
           </p:cNvPr>
@@ -16641,7 +16664,7 @@
           <p:cNvPr id="11" name="step-body-0">
             <a:extLst xmlns:a="http://schemas.openxmlformats.org/drawingml/2006/main">
               <a:ext uri="{FF2B5EF4-FFF2-40B4-BE49-F238E27FC236}">
-                <a16:creationId xmlns:a16="http://schemas.microsoft.com/office/drawing/2014/main" id="{0260845D-95F4-4A64-97FD-33C2B7FA184B}"/>
+                <a16:creationId xmlns:a16="http://schemas.microsoft.com/office/drawing/2014/main" id="{8CCC34C5-9038-4CCE-9AEB-2D5FBA248061}"/>
               </a:ext>
             </a:extLst>
           </p:cNvPr>
@@ -16823,7 +16846,7 @@
           <p:cNvPr id="12" name="step-dot-1">
             <a:extLst xmlns:a="http://schemas.openxmlformats.org/drawingml/2006/main">
               <a:ext uri="{FF2B5EF4-FFF2-40B4-BE49-F238E27FC236}">
-                <a16:creationId xmlns:a16="http://schemas.microsoft.com/office/drawing/2014/main" id="{D9EECF55-B478-4354-9D12-AA76A45E728B}"/>
+                <a16:creationId xmlns:a16="http://schemas.microsoft.com/office/drawing/2014/main" id="{79BBB5A9-092D-4D71-AE61-68521607CE35}"/>
               </a:ext>
             </a:extLst>
           </p:cNvPr>
@@ -16854,7 +16877,7 @@
           <p:cNvPr id="13" name="step-number-1">
             <a:extLst xmlns:a="http://schemas.openxmlformats.org/drawingml/2006/main">
               <a:ext uri="{FF2B5EF4-FFF2-40B4-BE49-F238E27FC236}">
-                <a16:creationId xmlns:a16="http://schemas.microsoft.com/office/drawing/2014/main" id="{CCA4AEE8-FCC5-43BF-A9B2-F516B4FD0C2C}"/>
+                <a16:creationId xmlns:a16="http://schemas.microsoft.com/office/drawing/2014/main" id="{68E850CC-B5BB-42C3-9575-CEE258B794E0}"/>
               </a:ext>
             </a:extLst>
           </p:cNvPr>
@@ -17013,7 +17036,7 @@
           <p:cNvPr id="14" name="step-heading-1">
             <a:extLst xmlns:a="http://schemas.openxmlformats.org/drawingml/2006/main">
               <a:ext uri="{FF2B5EF4-FFF2-40B4-BE49-F238E27FC236}">
-                <a16:creationId xmlns:a16="http://schemas.microsoft.com/office/drawing/2014/main" id="{2E58732B-7CD9-4A57-90C0-5B1786746595}"/>
+                <a16:creationId xmlns:a16="http://schemas.microsoft.com/office/drawing/2014/main" id="{9CB7078C-C346-4941-957E-C1C0D86FD505}"/>
               </a:ext>
             </a:extLst>
           </p:cNvPr>
@@ -17172,7 +17195,7 @@
           <p:cNvPr id="15" name="step-body-1">
             <a:extLst xmlns:a="http://schemas.openxmlformats.org/drawingml/2006/main">
               <a:ext uri="{FF2B5EF4-FFF2-40B4-BE49-F238E27FC236}">
-                <a16:creationId xmlns:a16="http://schemas.microsoft.com/office/drawing/2014/main" id="{009E402B-9B58-4EAE-9DCD-1CFBDC79285F}"/>
+                <a16:creationId xmlns:a16="http://schemas.microsoft.com/office/drawing/2014/main" id="{276C17E7-B802-4D33-9EA2-BF395219F9A9}"/>
               </a:ext>
             </a:extLst>
           </p:cNvPr>
@@ -17354,7 +17377,7 @@
           <p:cNvPr id="16" name="step-dot-2">
             <a:extLst xmlns:a="http://schemas.openxmlformats.org/drawingml/2006/main">
               <a:ext uri="{FF2B5EF4-FFF2-40B4-BE49-F238E27FC236}">
-                <a16:creationId xmlns:a16="http://schemas.microsoft.com/office/drawing/2014/main" id="{F2014765-2FBD-45EC-9568-A6BA75B0E8CB}"/>
+                <a16:creationId xmlns:a16="http://schemas.microsoft.com/office/drawing/2014/main" id="{15DEB4FF-0432-4BA3-9DA2-3A9FD25E6069}"/>
               </a:ext>
             </a:extLst>
           </p:cNvPr>
@@ -17385,7 +17408,7 @@
           <p:cNvPr id="17" name="step-number-2">
             <a:extLst xmlns:a="http://schemas.openxmlformats.org/drawingml/2006/main">
               <a:ext uri="{FF2B5EF4-FFF2-40B4-BE49-F238E27FC236}">
-                <a16:creationId xmlns:a16="http://schemas.microsoft.com/office/drawing/2014/main" id="{C5AB17BB-90AA-47A8-AF41-7746C532F590}"/>
+                <a16:creationId xmlns:a16="http://schemas.microsoft.com/office/drawing/2014/main" id="{A8E8E6AB-F468-4A4C-82D4-45278E1C28B6}"/>
               </a:ext>
             </a:extLst>
           </p:cNvPr>
@@ -17544,7 +17567,7 @@
           <p:cNvPr id="18" name="step-heading-2">
             <a:extLst xmlns:a="http://schemas.openxmlformats.org/drawingml/2006/main">
               <a:ext uri="{FF2B5EF4-FFF2-40B4-BE49-F238E27FC236}">
-                <a16:creationId xmlns:a16="http://schemas.microsoft.com/office/drawing/2014/main" id="{AA8CD2CF-3014-4BA8-A4CB-48E6A955A6BA}"/>
+                <a16:creationId xmlns:a16="http://schemas.microsoft.com/office/drawing/2014/main" id="{C6B8DE03-9A50-45B0-BA08-C53F6B6C72B5}"/>
               </a:ext>
             </a:extLst>
           </p:cNvPr>
@@ -17703,7 +17726,7 @@
           <p:cNvPr id="19" name="step-body-2">
             <a:extLst xmlns:a="http://schemas.openxmlformats.org/drawingml/2006/main">
               <a:ext uri="{FF2B5EF4-FFF2-40B4-BE49-F238E27FC236}">
-                <a16:creationId xmlns:a16="http://schemas.microsoft.com/office/drawing/2014/main" id="{4B7D3681-A23E-4A9C-AB6B-EF536B5D5CFC}"/>
+                <a16:creationId xmlns:a16="http://schemas.microsoft.com/office/drawing/2014/main" id="{102DF60A-49A6-4E9C-925A-ADFE6F6CEBE0}"/>
               </a:ext>
             </a:extLst>
           </p:cNvPr>
@@ -17885,7 +17908,7 @@
           <p:cNvPr id="20" name="step-dot-3">
             <a:extLst xmlns:a="http://schemas.openxmlformats.org/drawingml/2006/main">
               <a:ext uri="{FF2B5EF4-FFF2-40B4-BE49-F238E27FC236}">
-                <a16:creationId xmlns:a16="http://schemas.microsoft.com/office/drawing/2014/main" id="{3A996250-15B5-4E60-B815-0AFF318E5497}"/>
+                <a16:creationId xmlns:a16="http://schemas.microsoft.com/office/drawing/2014/main" id="{17044E31-D966-4895-926C-72355DEC0764}"/>
               </a:ext>
             </a:extLst>
           </p:cNvPr>
@@ -17916,7 +17939,7 @@
           <p:cNvPr id="21" name="step-number-3">
             <a:extLst xmlns:a="http://schemas.openxmlformats.org/drawingml/2006/main">
               <a:ext uri="{FF2B5EF4-FFF2-40B4-BE49-F238E27FC236}">
-                <a16:creationId xmlns:a16="http://schemas.microsoft.com/office/drawing/2014/main" id="{B0FD5BFF-C690-430C-9C7D-D2E98F8BA654}"/>
+                <a16:creationId xmlns:a16="http://schemas.microsoft.com/office/drawing/2014/main" id="{82DA1F10-0F7A-477A-A887-E987D10C4FC2}"/>
               </a:ext>
             </a:extLst>
           </p:cNvPr>
@@ -18075,7 +18098,7 @@
           <p:cNvPr id="22" name="step-heading-3">
             <a:extLst xmlns:a="http://schemas.openxmlformats.org/drawingml/2006/main">
               <a:ext uri="{FF2B5EF4-FFF2-40B4-BE49-F238E27FC236}">
-                <a16:creationId xmlns:a16="http://schemas.microsoft.com/office/drawing/2014/main" id="{6C33AF5A-FCB9-4A02-9476-33A2D320905E}"/>
+                <a16:creationId xmlns:a16="http://schemas.microsoft.com/office/drawing/2014/main" id="{11A8AD92-538D-4DB2-897B-31F347A57BFC}"/>
               </a:ext>
             </a:extLst>
           </p:cNvPr>
@@ -18234,7 +18257,7 @@
           <p:cNvPr id="23" name="step-body-3">
             <a:extLst xmlns:a="http://schemas.openxmlformats.org/drawingml/2006/main">
               <a:ext uri="{FF2B5EF4-FFF2-40B4-BE49-F238E27FC236}">
-                <a16:creationId xmlns:a16="http://schemas.microsoft.com/office/drawing/2014/main" id="{F3D73646-51CE-4BF6-953F-1EAB5950E7CA}"/>
+                <a16:creationId xmlns:a16="http://schemas.microsoft.com/office/drawing/2014/main" id="{D0C2846F-27B6-4AB3-920D-ACB1780D9393}"/>
               </a:ext>
             </a:extLst>
           </p:cNvPr>
@@ -18416,7 +18439,7 @@
           <p:cNvPr id="24" name="step-dot-4">
             <a:extLst xmlns:a="http://schemas.openxmlformats.org/drawingml/2006/main">
               <a:ext uri="{FF2B5EF4-FFF2-40B4-BE49-F238E27FC236}">
-                <a16:creationId xmlns:a16="http://schemas.microsoft.com/office/drawing/2014/main" id="{238731EC-7764-433D-9E43-B94B14F903B5}"/>
+                <a16:creationId xmlns:a16="http://schemas.microsoft.com/office/drawing/2014/main" id="{99768DBE-0F49-4F5D-85DB-00C985CDF35B}"/>
               </a:ext>
             </a:extLst>
           </p:cNvPr>
@@ -18447,7 +18470,7 @@
           <p:cNvPr id="25" name="step-number-4">
             <a:extLst xmlns:a="http://schemas.openxmlformats.org/drawingml/2006/main">
               <a:ext uri="{FF2B5EF4-FFF2-40B4-BE49-F238E27FC236}">
-                <a16:creationId xmlns:a16="http://schemas.microsoft.com/office/drawing/2014/main" id="{50866EF1-2CD9-4C3A-BF9E-3227EE04838B}"/>
+                <a16:creationId xmlns:a16="http://schemas.microsoft.com/office/drawing/2014/main" id="{B0CA0B73-70C5-49F9-B549-069F70AFE787}"/>
               </a:ext>
             </a:extLst>
           </p:cNvPr>
@@ -18606,7 +18629,7 @@
           <p:cNvPr id="26" name="step-heading-4">
             <a:extLst xmlns:a="http://schemas.openxmlformats.org/drawingml/2006/main">
               <a:ext uri="{FF2B5EF4-FFF2-40B4-BE49-F238E27FC236}">
-                <a16:creationId xmlns:a16="http://schemas.microsoft.com/office/drawing/2014/main" id="{781324AA-93D9-49A9-A267-CA39C4D7EE25}"/>
+                <a16:creationId xmlns:a16="http://schemas.microsoft.com/office/drawing/2014/main" id="{EECC9212-449F-4D08-B78C-EED98C316F85}"/>
               </a:ext>
             </a:extLst>
           </p:cNvPr>
@@ -18765,7 +18788,7 @@
           <p:cNvPr id="27" name="step-body-4">
             <a:extLst xmlns:a="http://schemas.openxmlformats.org/drawingml/2006/main">
               <a:ext uri="{FF2B5EF4-FFF2-40B4-BE49-F238E27FC236}">
-                <a16:creationId xmlns:a16="http://schemas.microsoft.com/office/drawing/2014/main" id="{B11F944B-E968-43B1-AFA2-3124D4C1985D}"/>
+                <a16:creationId xmlns:a16="http://schemas.microsoft.com/office/drawing/2014/main" id="{8E8774F9-EA43-437C-BD29-5B9ED0E4088B}"/>
               </a:ext>
             </a:extLst>
           </p:cNvPr>
@@ -18947,7 +18970,7 @@
           <p:cNvPr id="28" name="step-dot-5">
             <a:extLst xmlns:a="http://schemas.openxmlformats.org/drawingml/2006/main">
               <a:ext uri="{FF2B5EF4-FFF2-40B4-BE49-F238E27FC236}">
-                <a16:creationId xmlns:a16="http://schemas.microsoft.com/office/drawing/2014/main" id="{CF67AFD8-6307-4F2F-B2D8-9227C349FAB6}"/>
+                <a16:creationId xmlns:a16="http://schemas.microsoft.com/office/drawing/2014/main" id="{E25AF487-F9A1-488A-A018-C697FD1167A4}"/>
               </a:ext>
             </a:extLst>
           </p:cNvPr>
@@ -18978,7 +19001,7 @@
           <p:cNvPr id="29" name="step-number-5">
             <a:extLst xmlns:a="http://schemas.openxmlformats.org/drawingml/2006/main">
               <a:ext uri="{FF2B5EF4-FFF2-40B4-BE49-F238E27FC236}">
-                <a16:creationId xmlns:a16="http://schemas.microsoft.com/office/drawing/2014/main" id="{3FFB4A6C-7C9C-4D02-A1AF-FDC3C8FF33A3}"/>
+                <a16:creationId xmlns:a16="http://schemas.microsoft.com/office/drawing/2014/main" id="{3AC60AA4-24F6-462D-9848-4F8C6E93F409}"/>
               </a:ext>
             </a:extLst>
           </p:cNvPr>
@@ -19137,7 +19160,7 @@
           <p:cNvPr id="30" name="step-heading-5">
             <a:extLst xmlns:a="http://schemas.openxmlformats.org/drawingml/2006/main">
               <a:ext uri="{FF2B5EF4-FFF2-40B4-BE49-F238E27FC236}">
-                <a16:creationId xmlns:a16="http://schemas.microsoft.com/office/drawing/2014/main" id="{4D0FCA21-E08C-4E65-B5CC-5601D836400E}"/>
+                <a16:creationId xmlns:a16="http://schemas.microsoft.com/office/drawing/2014/main" id="{327967FA-9C8C-43B5-A572-01001C77C328}"/>
               </a:ext>
             </a:extLst>
           </p:cNvPr>
@@ -19296,7 +19319,7 @@
           <p:cNvPr id="31" name="step-body-5">
             <a:extLst xmlns:a="http://schemas.openxmlformats.org/drawingml/2006/main">
               <a:ext uri="{FF2B5EF4-FFF2-40B4-BE49-F238E27FC236}">
-                <a16:creationId xmlns:a16="http://schemas.microsoft.com/office/drawing/2014/main" id="{36F3FE98-8017-4BE7-9807-26EF78B0027D}"/>
+                <a16:creationId xmlns:a16="http://schemas.microsoft.com/office/drawing/2014/main" id="{8E254864-251B-44FF-A973-72C49514950F}"/>
               </a:ext>
             </a:extLst>
           </p:cNvPr>
@@ -19478,7 +19501,7 @@
           <p:cNvPr id="32" name="lifecycle-limit">
             <a:extLst xmlns:a="http://schemas.openxmlformats.org/drawingml/2006/main">
               <a:ext uri="{FF2B5EF4-FFF2-40B4-BE49-F238E27FC236}">
-                <a16:creationId xmlns:a16="http://schemas.microsoft.com/office/drawing/2014/main" id="{5095E71E-8E5D-4D60-93EC-BF574441D233}"/>
+                <a16:creationId xmlns:a16="http://schemas.microsoft.com/office/drawing/2014/main" id="{F4DF6266-C044-4191-BEB6-392DC6823120}"/>
               </a:ext>
             </a:extLst>
           </p:cNvPr>
@@ -19635,7 +19658,7 @@
     </p:spTree>
     <p:extLst>
       <p:ext uri="{BB962C8B-B14F-4D97-AF65-F5344CB8AC3E}">
-        <p14:creationId xmlns:p14="http://schemas.microsoft.com/office/powerpoint/2010/main" val="2006458268"/>
+        <p14:creationId xmlns:p14="http://schemas.microsoft.com/office/powerpoint/2010/main" val="1359568563"/>
       </p:ext>
     </p:extLst>
   </p:cSld>
@@ -19666,7 +19689,7 @@
           <p:cNvPr id="19" name="section-5">
             <a:extLst xmlns:a="http://schemas.openxmlformats.org/drawingml/2006/main">
               <a:ext uri="{FF2B5EF4-FFF2-40B4-BE49-F238E27FC236}">
-                <a16:creationId xmlns:a16="http://schemas.microsoft.com/office/drawing/2014/main" id="{B20BC7B1-35F5-4E18-8AD6-4CA4E4EC55FA}"/>
+                <a16:creationId xmlns:a16="http://schemas.microsoft.com/office/drawing/2014/main" id="{EB435CBD-9A33-438C-B67B-04588F6AF377}"/>
               </a:ext>
             </a:extLst>
           </p:cNvPr>
@@ -19825,7 +19848,7 @@
           <p:cNvPr id="2" name="title-5">
             <a:extLst xmlns:a="http://schemas.openxmlformats.org/drawingml/2006/main">
               <a:ext uri="{FF2B5EF4-FFF2-40B4-BE49-F238E27FC236}">
-                <a16:creationId xmlns:a16="http://schemas.microsoft.com/office/drawing/2014/main" id="{8767FB29-C46D-4411-9A7A-CCCFB8C92F2C}"/>
+                <a16:creationId xmlns:a16="http://schemas.microsoft.com/office/drawing/2014/main" id="{83F9625F-5378-4F13-923E-21E1D7DC8B45}"/>
               </a:ext>
             </a:extLst>
           </p:cNvPr>
@@ -19984,7 +20007,7 @@
           <p:cNvPr id="3" name="title-rule-5">
             <a:extLst xmlns:a="http://schemas.openxmlformats.org/drawingml/2006/main">
               <a:ext uri="{FF2B5EF4-FFF2-40B4-BE49-F238E27FC236}">
-                <a16:creationId xmlns:a16="http://schemas.microsoft.com/office/drawing/2014/main" id="{CCCF8A15-FE65-49F9-948E-290BE20B28E2}"/>
+                <a16:creationId xmlns:a16="http://schemas.microsoft.com/office/drawing/2014/main" id="{865A3017-B86B-4F2C-B43D-0BDACAD65C80}"/>
               </a:ext>
             </a:extLst>
           </p:cNvPr>
@@ -20015,7 +20038,7 @@
           <p:cNvPr id="4" name="footer-rule-5">
             <a:extLst xmlns:a="http://schemas.openxmlformats.org/drawingml/2006/main">
               <a:ext uri="{FF2B5EF4-FFF2-40B4-BE49-F238E27FC236}">
-                <a16:creationId xmlns:a16="http://schemas.microsoft.com/office/drawing/2014/main" id="{89524641-FD70-4F3A-B3DD-EBCE7F3BBC77}"/>
+                <a16:creationId xmlns:a16="http://schemas.microsoft.com/office/drawing/2014/main" id="{048C6C4A-D2E1-44A0-AD7D-2B09A55A4429}"/>
               </a:ext>
             </a:extLst>
           </p:cNvPr>
@@ -20046,7 +20069,7 @@
           <p:cNvPr id="5" name="footer-5">
             <a:extLst xmlns:a="http://schemas.openxmlformats.org/drawingml/2006/main">
               <a:ext uri="{FF2B5EF4-FFF2-40B4-BE49-F238E27FC236}">
-                <a16:creationId xmlns:a16="http://schemas.microsoft.com/office/drawing/2014/main" id="{AE4C4F1A-F49A-4182-8ECC-727DDFE762F2}"/>
+                <a16:creationId xmlns:a16="http://schemas.microsoft.com/office/drawing/2014/main" id="{D0762C90-E103-4B9C-A5AE-D161E17EA247}"/>
               </a:ext>
             </a:extLst>
           </p:cNvPr>
@@ -20205,7 +20228,7 @@
           <p:cNvPr id="6" name="page-5">
             <a:extLst xmlns:a="http://schemas.openxmlformats.org/drawingml/2006/main">
               <a:ext uri="{FF2B5EF4-FFF2-40B4-BE49-F238E27FC236}">
-                <a16:creationId xmlns:a16="http://schemas.microsoft.com/office/drawing/2014/main" id="{C869D87D-DB35-4BCB-9986-4EB85C6A87FD}"/>
+                <a16:creationId xmlns:a16="http://schemas.microsoft.com/office/drawing/2014/main" id="{6032FB20-57F5-40DE-91E0-4D85555D70AB}"/>
               </a:ext>
             </a:extLst>
           </p:cNvPr>
@@ -20364,7 +20387,7 @@
           <p:cNvPr id="7" name="control-a-marker">
             <a:extLst xmlns:a="http://schemas.openxmlformats.org/drawingml/2006/main">
               <a:ext uri="{FF2B5EF4-FFF2-40B4-BE49-F238E27FC236}">
-                <a16:creationId xmlns:a16="http://schemas.microsoft.com/office/drawing/2014/main" id="{24A6F764-8B77-48C8-AF86-EA6CB7553112}"/>
+                <a16:creationId xmlns:a16="http://schemas.microsoft.com/office/drawing/2014/main" id="{DCE1D8B8-814D-4BF5-8242-6DA646F59100}"/>
               </a:ext>
             </a:extLst>
           </p:cNvPr>
@@ -20395,7 +20418,7 @@
           <p:cNvPr id="8" name="control-a-heading">
             <a:extLst xmlns:a="http://schemas.openxmlformats.org/drawingml/2006/main">
               <a:ext uri="{FF2B5EF4-FFF2-40B4-BE49-F238E27FC236}">
-                <a16:creationId xmlns:a16="http://schemas.microsoft.com/office/drawing/2014/main" id="{F769C545-7E84-4508-BBCC-967D7D5C1DEE}"/>
+                <a16:creationId xmlns:a16="http://schemas.microsoft.com/office/drawing/2014/main" id="{321F7297-FC65-4551-BB28-BA9DFECA2990}"/>
               </a:ext>
             </a:extLst>
           </p:cNvPr>
@@ -20554,7 +20577,7 @@
           <p:cNvPr id="9" name="control-a-body">
             <a:extLst xmlns:a="http://schemas.openxmlformats.org/drawingml/2006/main">
               <a:ext uri="{FF2B5EF4-FFF2-40B4-BE49-F238E27FC236}">
-                <a16:creationId xmlns:a16="http://schemas.microsoft.com/office/drawing/2014/main" id="{2E692A2F-0AEF-4655-9BF8-E42857720886}"/>
+                <a16:creationId xmlns:a16="http://schemas.microsoft.com/office/drawing/2014/main" id="{68C0ACC0-788F-4D8A-938E-5DAED5AD59AF}"/>
               </a:ext>
             </a:extLst>
           </p:cNvPr>
@@ -20713,7 +20736,7 @@
           <p:cNvPr id="10" name="control-b-marker">
             <a:extLst xmlns:a="http://schemas.openxmlformats.org/drawingml/2006/main">
               <a:ext uri="{FF2B5EF4-FFF2-40B4-BE49-F238E27FC236}">
-                <a16:creationId xmlns:a16="http://schemas.microsoft.com/office/drawing/2014/main" id="{17FACC5D-4070-4A1B-B4E3-5C64BC7558F9}"/>
+                <a16:creationId xmlns:a16="http://schemas.microsoft.com/office/drawing/2014/main" id="{8D00E699-885B-4DCC-80B8-3A6E73B32703}"/>
               </a:ext>
             </a:extLst>
           </p:cNvPr>
@@ -20744,7 +20767,7 @@
           <p:cNvPr id="11" name="control-b-heading">
             <a:extLst xmlns:a="http://schemas.openxmlformats.org/drawingml/2006/main">
               <a:ext uri="{FF2B5EF4-FFF2-40B4-BE49-F238E27FC236}">
-                <a16:creationId xmlns:a16="http://schemas.microsoft.com/office/drawing/2014/main" id="{426AB66D-7BBE-4058-8EDF-DBAA6E19F236}"/>
+                <a16:creationId xmlns:a16="http://schemas.microsoft.com/office/drawing/2014/main" id="{C520951B-93B0-419B-AEB2-C8F94925881F}"/>
               </a:ext>
             </a:extLst>
           </p:cNvPr>
@@ -20903,7 +20926,7 @@
           <p:cNvPr id="12" name="control-b-body">
             <a:extLst xmlns:a="http://schemas.openxmlformats.org/drawingml/2006/main">
               <a:ext uri="{FF2B5EF4-FFF2-40B4-BE49-F238E27FC236}">
-                <a16:creationId xmlns:a16="http://schemas.microsoft.com/office/drawing/2014/main" id="{BA061793-A91C-40E4-A003-6B818979EED4}"/>
+                <a16:creationId xmlns:a16="http://schemas.microsoft.com/office/drawing/2014/main" id="{5BED8AD5-A5DF-4F7D-9A92-147430D8775C}"/>
               </a:ext>
             </a:extLst>
           </p:cNvPr>
@@ -21062,7 +21085,7 @@
           <p:cNvPr id="13" name="control-c-marker">
             <a:extLst xmlns:a="http://schemas.openxmlformats.org/drawingml/2006/main">
               <a:ext uri="{FF2B5EF4-FFF2-40B4-BE49-F238E27FC236}">
-                <a16:creationId xmlns:a16="http://schemas.microsoft.com/office/drawing/2014/main" id="{90C8DCAA-3D00-4B20-AEE5-4158090ECA08}"/>
+                <a16:creationId xmlns:a16="http://schemas.microsoft.com/office/drawing/2014/main" id="{2B08D435-CD9F-4F86-A859-E9311AEA6524}"/>
               </a:ext>
             </a:extLst>
           </p:cNvPr>
@@ -21093,7 +21116,7 @@
           <p:cNvPr id="14" name="control-c-heading">
             <a:extLst xmlns:a="http://schemas.openxmlformats.org/drawingml/2006/main">
               <a:ext uri="{FF2B5EF4-FFF2-40B4-BE49-F238E27FC236}">
-                <a16:creationId xmlns:a16="http://schemas.microsoft.com/office/drawing/2014/main" id="{6B98246F-7A8D-408E-9053-7B2277E3F9CE}"/>
+                <a16:creationId xmlns:a16="http://schemas.microsoft.com/office/drawing/2014/main" id="{57C4BF20-EBFC-4721-A268-1B876349CB95}"/>
               </a:ext>
             </a:extLst>
           </p:cNvPr>
@@ -21252,7 +21275,7 @@
           <p:cNvPr id="15" name="control-c-body">
             <a:extLst xmlns:a="http://schemas.openxmlformats.org/drawingml/2006/main">
               <a:ext uri="{FF2B5EF4-FFF2-40B4-BE49-F238E27FC236}">
-                <a16:creationId xmlns:a16="http://schemas.microsoft.com/office/drawing/2014/main" id="{6E796CB0-65D3-4E6A-9390-E3920F2D13F0}"/>
+                <a16:creationId xmlns:a16="http://schemas.microsoft.com/office/drawing/2014/main" id="{DA82616B-D1A0-4E46-84E8-E1C2A03C6E14}"/>
               </a:ext>
             </a:extLst>
           </p:cNvPr>
@@ -21411,7 +21434,7 @@
           <p:cNvPr id="16" name="control-d-marker">
             <a:extLst xmlns:a="http://schemas.openxmlformats.org/drawingml/2006/main">
               <a:ext uri="{FF2B5EF4-FFF2-40B4-BE49-F238E27FC236}">
-                <a16:creationId xmlns:a16="http://schemas.microsoft.com/office/drawing/2014/main" id="{06D18AFC-3466-4DD3-868C-02C56D5DB8E1}"/>
+                <a16:creationId xmlns:a16="http://schemas.microsoft.com/office/drawing/2014/main" id="{3777B185-23C5-4869-9681-BF65CFE75D44}"/>
               </a:ext>
             </a:extLst>
           </p:cNvPr>
@@ -21442,7 +21465,7 @@
           <p:cNvPr id="17" name="control-d-heading">
             <a:extLst xmlns:a="http://schemas.openxmlformats.org/drawingml/2006/main">
               <a:ext uri="{FF2B5EF4-FFF2-40B4-BE49-F238E27FC236}">
-                <a16:creationId xmlns:a16="http://schemas.microsoft.com/office/drawing/2014/main" id="{FB9D0F2F-BF37-42B9-84BE-7632F0D6FB00}"/>
+                <a16:creationId xmlns:a16="http://schemas.microsoft.com/office/drawing/2014/main" id="{A4C0D8F5-99CA-4AE1-B7F0-8CCD79363738}"/>
               </a:ext>
             </a:extLst>
           </p:cNvPr>
@@ -21601,7 +21624,7 @@
           <p:cNvPr id="18" name="control-d-body">
             <a:extLst xmlns:a="http://schemas.openxmlformats.org/drawingml/2006/main">
               <a:ext uri="{FF2B5EF4-FFF2-40B4-BE49-F238E27FC236}">
-                <a16:creationId xmlns:a16="http://schemas.microsoft.com/office/drawing/2014/main" id="{6614FC3F-0D7E-4635-8BAD-9D2D7168A1AB}"/>
+                <a16:creationId xmlns:a16="http://schemas.microsoft.com/office/drawing/2014/main" id="{F687D1FE-FD63-40BB-ACC8-848D658B0AE0}"/>
               </a:ext>
             </a:extLst>
           </p:cNvPr>
@@ -21758,7 +21781,7 @@
     </p:spTree>
     <p:extLst>
       <p:ext uri="{BB962C8B-B14F-4D97-AF65-F5344CB8AC3E}">
-        <p14:creationId xmlns:p14="http://schemas.microsoft.com/office/powerpoint/2010/main" val="882846549"/>
+        <p14:creationId xmlns:p14="http://schemas.microsoft.com/office/powerpoint/2010/main" val="2027631821"/>
       </p:ext>
     </p:extLst>
   </p:cSld>
@@ -21789,7 +21812,7 @@
           <p:cNvPr id="18" name="section-6">
             <a:extLst xmlns:a="http://schemas.openxmlformats.org/drawingml/2006/main">
               <a:ext uri="{FF2B5EF4-FFF2-40B4-BE49-F238E27FC236}">
-                <a16:creationId xmlns:a16="http://schemas.microsoft.com/office/drawing/2014/main" id="{24B97C62-C4EC-451C-AD03-01A02C574713}"/>
+                <a16:creationId xmlns:a16="http://schemas.microsoft.com/office/drawing/2014/main" id="{B46413CB-CDCB-43ED-907D-98E1D30F74F7}"/>
               </a:ext>
             </a:extLst>
           </p:cNvPr>
@@ -21948,7 +21971,7 @@
           <p:cNvPr id="2" name="title-6">
             <a:extLst xmlns:a="http://schemas.openxmlformats.org/drawingml/2006/main">
               <a:ext uri="{FF2B5EF4-FFF2-40B4-BE49-F238E27FC236}">
-                <a16:creationId xmlns:a16="http://schemas.microsoft.com/office/drawing/2014/main" id="{11CD5C78-8CB2-49B5-95CF-7497ED624814}"/>
+                <a16:creationId xmlns:a16="http://schemas.microsoft.com/office/drawing/2014/main" id="{56751DBC-A161-4C38-969E-06984A398E32}"/>
               </a:ext>
             </a:extLst>
           </p:cNvPr>
@@ -22107,7 +22130,7 @@
           <p:cNvPr id="3" name="title-rule-6">
             <a:extLst xmlns:a="http://schemas.openxmlformats.org/drawingml/2006/main">
               <a:ext uri="{FF2B5EF4-FFF2-40B4-BE49-F238E27FC236}">
-                <a16:creationId xmlns:a16="http://schemas.microsoft.com/office/drawing/2014/main" id="{3475FF2C-F3D1-49FB-A275-3167FCA73C44}"/>
+                <a16:creationId xmlns:a16="http://schemas.microsoft.com/office/drawing/2014/main" id="{162ABD44-0CB8-4B61-AAEB-B450521E6A3E}"/>
               </a:ext>
             </a:extLst>
           </p:cNvPr>
@@ -22138,7 +22161,7 @@
           <p:cNvPr id="4" name="footer-rule-6">
             <a:extLst xmlns:a="http://schemas.openxmlformats.org/drawingml/2006/main">
               <a:ext uri="{FF2B5EF4-FFF2-40B4-BE49-F238E27FC236}">
-                <a16:creationId xmlns:a16="http://schemas.microsoft.com/office/drawing/2014/main" id="{2B0AEC52-4F16-4FFC-9681-4F2581272328}"/>
+                <a16:creationId xmlns:a16="http://schemas.microsoft.com/office/drawing/2014/main" id="{B92FD08F-D6B9-4F6B-95ED-0103B3BD10F7}"/>
               </a:ext>
             </a:extLst>
           </p:cNvPr>
@@ -22169,7 +22192,7 @@
           <p:cNvPr id="5" name="footer-6">
             <a:extLst xmlns:a="http://schemas.openxmlformats.org/drawingml/2006/main">
               <a:ext uri="{FF2B5EF4-FFF2-40B4-BE49-F238E27FC236}">
-                <a16:creationId xmlns:a16="http://schemas.microsoft.com/office/drawing/2014/main" id="{9ECB8129-2F7E-4C57-90B2-369BBB5248E4}"/>
+                <a16:creationId xmlns:a16="http://schemas.microsoft.com/office/drawing/2014/main" id="{178969DD-09AE-4709-9F17-DA251BC418E2}"/>
               </a:ext>
             </a:extLst>
           </p:cNvPr>
@@ -22328,7 +22351,7 @@
           <p:cNvPr id="6" name="page-6">
             <a:extLst xmlns:a="http://schemas.openxmlformats.org/drawingml/2006/main">
               <a:ext uri="{FF2B5EF4-FFF2-40B4-BE49-F238E27FC236}">
-                <a16:creationId xmlns:a16="http://schemas.microsoft.com/office/drawing/2014/main" id="{E3585A09-4262-410F-A208-512A824DE940}"/>
+                <a16:creationId xmlns:a16="http://schemas.microsoft.com/office/drawing/2014/main" id="{A13EDDE5-8E78-4105-9AA9-C1FAD22F7E89}"/>
               </a:ext>
             </a:extLst>
           </p:cNvPr>
@@ -22487,7 +22510,7 @@
           <p:cNvPr id="7" name="eval-count">
             <a:extLst xmlns:a="http://schemas.openxmlformats.org/drawingml/2006/main">
               <a:ext uri="{FF2B5EF4-FFF2-40B4-BE49-F238E27FC236}">
-                <a16:creationId xmlns:a16="http://schemas.microsoft.com/office/drawing/2014/main" id="{8D570138-54DF-46FB-9B9E-46EBE50D8031}"/>
+                <a16:creationId xmlns:a16="http://schemas.microsoft.com/office/drawing/2014/main" id="{6526E559-7A7E-420E-B90D-B489B906FBE9}"/>
               </a:ext>
             </a:extLst>
           </p:cNvPr>
@@ -22646,7 +22669,7 @@
           <p:cNvPr id="8" name="eval-label">
             <a:extLst xmlns:a="http://schemas.openxmlformats.org/drawingml/2006/main">
               <a:ext uri="{FF2B5EF4-FFF2-40B4-BE49-F238E27FC236}">
-                <a16:creationId xmlns:a16="http://schemas.microsoft.com/office/drawing/2014/main" id="{1890DD27-F106-457C-8CFD-6455C92652F3}"/>
+                <a16:creationId xmlns:a16="http://schemas.microsoft.com/office/drawing/2014/main" id="{D7A8FDFA-338B-4523-92D2-4F4C6285AD72}"/>
               </a:ext>
             </a:extLst>
           </p:cNvPr>
@@ -22805,7 +22828,7 @@
           <p:cNvPr id="9" name="eval-divider">
             <a:extLst xmlns:a="http://schemas.openxmlformats.org/drawingml/2006/main">
               <a:ext uri="{FF2B5EF4-FFF2-40B4-BE49-F238E27FC236}">
-                <a16:creationId xmlns:a16="http://schemas.microsoft.com/office/drawing/2014/main" id="{6C519FE0-DE3D-4050-9F2A-FB1714E54025}"/>
+                <a16:creationId xmlns:a16="http://schemas.microsoft.com/office/drawing/2014/main" id="{5D6C7172-8019-4189-870D-FE49A4E277AE}"/>
               </a:ext>
             </a:extLst>
           </p:cNvPr>
@@ -22836,7 +22859,7 @@
           <p:cNvPr id="10" name="eval-valid">
             <a:extLst xmlns:a="http://schemas.openxmlformats.org/drawingml/2006/main">
               <a:ext uri="{FF2B5EF4-FFF2-40B4-BE49-F238E27FC236}">
-                <a16:creationId xmlns:a16="http://schemas.microsoft.com/office/drawing/2014/main" id="{6D90851D-E232-4EC6-BDF4-18D9C0EF52DB}"/>
+                <a16:creationId xmlns:a16="http://schemas.microsoft.com/office/drawing/2014/main" id="{7CEF1445-A380-4855-8112-3C0625209306}"/>
               </a:ext>
             </a:extLst>
           </p:cNvPr>
@@ -22995,7 +23018,7 @@
           <p:cNvPr id="11" name="eval-valid-caption">
             <a:extLst xmlns:a="http://schemas.openxmlformats.org/drawingml/2006/main">
               <a:ext uri="{FF2B5EF4-FFF2-40B4-BE49-F238E27FC236}">
-                <a16:creationId xmlns:a16="http://schemas.microsoft.com/office/drawing/2014/main" id="{A9934219-34D2-41EC-BABC-00B45D3D8DB3}"/>
+                <a16:creationId xmlns:a16="http://schemas.microsoft.com/office/drawing/2014/main" id="{8FF8C707-8F4C-4CCD-9C6D-F3C13ADBB582}"/>
               </a:ext>
             </a:extLst>
           </p:cNvPr>
@@ -23154,7 +23177,7 @@
           <p:cNvPr id="12" name="eval-invalid">
             <a:extLst xmlns:a="http://schemas.openxmlformats.org/drawingml/2006/main">
               <a:ext uri="{FF2B5EF4-FFF2-40B4-BE49-F238E27FC236}">
-                <a16:creationId xmlns:a16="http://schemas.microsoft.com/office/drawing/2014/main" id="{FB793616-2BC9-40EA-B38B-1E3C0C62ADF0}"/>
+                <a16:creationId xmlns:a16="http://schemas.microsoft.com/office/drawing/2014/main" id="{593ADEA0-1A89-4C0C-A48B-39ABCE9FEBC6}"/>
               </a:ext>
             </a:extLst>
           </p:cNvPr>
@@ -23313,7 +23336,7 @@
           <p:cNvPr id="13" name="eval-invalid-caption">
             <a:extLst xmlns:a="http://schemas.openxmlformats.org/drawingml/2006/main">
               <a:ext uri="{FF2B5EF4-FFF2-40B4-BE49-F238E27FC236}">
-                <a16:creationId xmlns:a16="http://schemas.microsoft.com/office/drawing/2014/main" id="{CEC57AA6-A539-4665-A77B-5D8C8579EDCA}"/>
+                <a16:creationId xmlns:a16="http://schemas.microsoft.com/office/drawing/2014/main" id="{8223A5B1-ACE1-4CF0-B55C-A73C8A45D7CE}"/>
               </a:ext>
             </a:extLst>
           </p:cNvPr>
@@ -23472,7 +23495,7 @@
           <p:cNvPr id="14" name="eval-modes-title">
             <a:extLst xmlns:a="http://schemas.openxmlformats.org/drawingml/2006/main">
               <a:ext uri="{FF2B5EF4-FFF2-40B4-BE49-F238E27FC236}">
-                <a16:creationId xmlns:a16="http://schemas.microsoft.com/office/drawing/2014/main" id="{F6F1D953-5417-4622-BD2E-DB5A9DD564F7}"/>
+                <a16:creationId xmlns:a16="http://schemas.microsoft.com/office/drawing/2014/main" id="{CB21CA3A-5AC5-41CA-B6F9-3A5576ABD56E}"/>
               </a:ext>
             </a:extLst>
           </p:cNvPr>
@@ -23631,7 +23654,7 @@
           <p:cNvPr id="15" name="eval-modes">
             <a:extLst xmlns:a="http://schemas.openxmlformats.org/drawingml/2006/main">
               <a:ext uri="{FF2B5EF4-FFF2-40B4-BE49-F238E27FC236}">
-                <a16:creationId xmlns:a16="http://schemas.microsoft.com/office/drawing/2014/main" id="{C0B5BD21-0158-423B-93C7-952CA8E6F913}"/>
+                <a16:creationId xmlns:a16="http://schemas.microsoft.com/office/drawing/2014/main" id="{4B7543CF-88FD-41B1-9FDE-821F2BFA1D78}"/>
               </a:ext>
             </a:extLst>
           </p:cNvPr>
@@ -23836,7 +23859,7 @@
           <p:cNvPr id="16" name="eval-replicates">
             <a:extLst xmlns:a="http://schemas.openxmlformats.org/drawingml/2006/main">
               <a:ext uri="{FF2B5EF4-FFF2-40B4-BE49-F238E27FC236}">
-                <a16:creationId xmlns:a16="http://schemas.microsoft.com/office/drawing/2014/main" id="{3141FD0E-0D17-4361-8DD6-2CD9CD35D9A1}"/>
+                <a16:creationId xmlns:a16="http://schemas.microsoft.com/office/drawing/2014/main" id="{C8705D47-A8AA-4ED1-9873-B5D8B1C8B40F}"/>
               </a:ext>
             </a:extLst>
           </p:cNvPr>
@@ -23995,7 +24018,7 @@
           <p:cNvPr id="17" name="eval-hash">
             <a:extLst xmlns:a="http://schemas.openxmlformats.org/drawingml/2006/main">
               <a:ext uri="{FF2B5EF4-FFF2-40B4-BE49-F238E27FC236}">
-                <a16:creationId xmlns:a16="http://schemas.microsoft.com/office/drawing/2014/main" id="{CB6225A4-C26D-49C8-B1FD-EF783AE0921B}"/>
+                <a16:creationId xmlns:a16="http://schemas.microsoft.com/office/drawing/2014/main" id="{62D590CF-DF3B-4BF6-AC73-1F889AE0BEA0}"/>
               </a:ext>
             </a:extLst>
           </p:cNvPr>
@@ -24152,7 +24175,7 @@
     </p:spTree>
     <p:extLst>
       <p:ext uri="{BB962C8B-B14F-4D97-AF65-F5344CB8AC3E}">
-        <p14:creationId xmlns:p14="http://schemas.microsoft.com/office/powerpoint/2010/main" val="720755667"/>
+        <p14:creationId xmlns:p14="http://schemas.microsoft.com/office/powerpoint/2010/main" val="1122468565"/>
       </p:ext>
     </p:extLst>
   </p:cSld>
@@ -24183,7 +24206,7 @@
           <p:cNvPr id="16" name="section-7">
             <a:extLst xmlns:a="http://schemas.openxmlformats.org/drawingml/2006/main">
               <a:ext uri="{FF2B5EF4-FFF2-40B4-BE49-F238E27FC236}">
-                <a16:creationId xmlns:a16="http://schemas.microsoft.com/office/drawing/2014/main" id="{2C001140-A67F-4E69-B81C-CB5FF857C730}"/>
+                <a16:creationId xmlns:a16="http://schemas.microsoft.com/office/drawing/2014/main" id="{8E9370D4-2FE5-4440-A134-756879D3DB4B}"/>
               </a:ext>
             </a:extLst>
           </p:cNvPr>
@@ -24342,7 +24365,7 @@
           <p:cNvPr id="2" name="title-7">
             <a:extLst xmlns:a="http://schemas.openxmlformats.org/drawingml/2006/main">
               <a:ext uri="{FF2B5EF4-FFF2-40B4-BE49-F238E27FC236}">
-                <a16:creationId xmlns:a16="http://schemas.microsoft.com/office/drawing/2014/main" id="{040EEA78-2743-4B7D-8E9F-C440B7C96978}"/>
+                <a16:creationId xmlns:a16="http://schemas.microsoft.com/office/drawing/2014/main" id="{70C7CD5B-7AF2-4EA5-9A7E-298D1E036AD3}"/>
               </a:ext>
             </a:extLst>
           </p:cNvPr>
@@ -24501,7 +24524,7 @@
           <p:cNvPr id="3" name="title-rule-7">
             <a:extLst xmlns:a="http://schemas.openxmlformats.org/drawingml/2006/main">
               <a:ext uri="{FF2B5EF4-FFF2-40B4-BE49-F238E27FC236}">
-                <a16:creationId xmlns:a16="http://schemas.microsoft.com/office/drawing/2014/main" id="{7BDCEC3D-CCC1-443C-9CC8-176E457D5490}"/>
+                <a16:creationId xmlns:a16="http://schemas.microsoft.com/office/drawing/2014/main" id="{E1E635F1-D77C-4F54-9DAE-275767D3A962}"/>
               </a:ext>
             </a:extLst>
           </p:cNvPr>
@@ -24532,7 +24555,7 @@
           <p:cNvPr id="4" name="footer-rule-7">
             <a:extLst xmlns:a="http://schemas.openxmlformats.org/drawingml/2006/main">
               <a:ext uri="{FF2B5EF4-FFF2-40B4-BE49-F238E27FC236}">
-                <a16:creationId xmlns:a16="http://schemas.microsoft.com/office/drawing/2014/main" id="{DFAEA3A8-EE6B-4744-AB86-94AFA776DAC7}"/>
+                <a16:creationId xmlns:a16="http://schemas.microsoft.com/office/drawing/2014/main" id="{A20AE678-37A6-4BB4-892A-A8B0EB612D27}"/>
               </a:ext>
             </a:extLst>
           </p:cNvPr>
@@ -24563,7 +24586,7 @@
           <p:cNvPr id="5" name="footer-7">
             <a:extLst xmlns:a="http://schemas.openxmlformats.org/drawingml/2006/main">
               <a:ext uri="{FF2B5EF4-FFF2-40B4-BE49-F238E27FC236}">
-                <a16:creationId xmlns:a16="http://schemas.microsoft.com/office/drawing/2014/main" id="{C15720F2-97B5-42A4-83E0-EEF23B36C0FF}"/>
+                <a16:creationId xmlns:a16="http://schemas.microsoft.com/office/drawing/2014/main" id="{B748E4DD-76AF-48EC-98A2-9EA6A3DDA2FC}"/>
               </a:ext>
             </a:extLst>
           </p:cNvPr>
@@ -24722,7 +24745,7 @@
           <p:cNvPr id="6" name="page-7">
             <a:extLst xmlns:a="http://schemas.openxmlformats.org/drawingml/2006/main">
               <a:ext uri="{FF2B5EF4-FFF2-40B4-BE49-F238E27FC236}">
-                <a16:creationId xmlns:a16="http://schemas.microsoft.com/office/drawing/2014/main" id="{1E85AF0C-DE2D-4485-83E3-B9F6E5C515B8}"/>
+                <a16:creationId xmlns:a16="http://schemas.microsoft.com/office/drawing/2014/main" id="{FD706C99-6C95-4306-82B8-0F21E700AA42}"/>
               </a:ext>
             </a:extLst>
           </p:cNvPr>
@@ -24881,7 +24904,7 @@
           <p:cNvPr id="7" name="findings-one">
             <a:extLst xmlns:a="http://schemas.openxmlformats.org/drawingml/2006/main">
               <a:ext uri="{FF2B5EF4-FFF2-40B4-BE49-F238E27FC236}">
-                <a16:creationId xmlns:a16="http://schemas.microsoft.com/office/drawing/2014/main" id="{F1066150-B0D8-4455-90A4-4C1EE30A2444}"/>
+                <a16:creationId xmlns:a16="http://schemas.microsoft.com/office/drawing/2014/main" id="{9E81F296-9FB2-4C74-8FE4-19829725B3FC}"/>
               </a:ext>
             </a:extLst>
           </p:cNvPr>
@@ -25040,7 +25063,7 @@
           <p:cNvPr id="8" name="findings-one-body">
             <a:extLst xmlns:a="http://schemas.openxmlformats.org/drawingml/2006/main">
               <a:ext uri="{FF2B5EF4-FFF2-40B4-BE49-F238E27FC236}">
-                <a16:creationId xmlns:a16="http://schemas.microsoft.com/office/drawing/2014/main" id="{25B8BFFC-A659-42B8-A4D9-B5E5D960C7FD}"/>
+                <a16:creationId xmlns:a16="http://schemas.microsoft.com/office/drawing/2014/main" id="{93393B7D-CF46-4FD6-9238-5689B56D7547}"/>
               </a:ext>
             </a:extLst>
           </p:cNvPr>
@@ -25199,7 +25222,7 @@
           <p:cNvPr id="9" name="findings-separator-1">
             <a:extLst xmlns:a="http://schemas.openxmlformats.org/drawingml/2006/main">
               <a:ext uri="{FF2B5EF4-FFF2-40B4-BE49-F238E27FC236}">
-                <a16:creationId xmlns:a16="http://schemas.microsoft.com/office/drawing/2014/main" id="{A636852C-95A0-4B39-A7B1-8CA9BC952853}"/>
+                <a16:creationId xmlns:a16="http://schemas.microsoft.com/office/drawing/2014/main" id="{D0789856-432F-43BD-B3E7-C8BB88A6AAC1}"/>
               </a:ext>
             </a:extLst>
           </p:cNvPr>
@@ -25230,7 +25253,7 @@
           <p:cNvPr id="10" name="findings-two">
             <a:extLst xmlns:a="http://schemas.openxmlformats.org/drawingml/2006/main">
               <a:ext uri="{FF2B5EF4-FFF2-40B4-BE49-F238E27FC236}">
-                <a16:creationId xmlns:a16="http://schemas.microsoft.com/office/drawing/2014/main" id="{E0CF5C6A-C2B2-4902-AED5-8EE76E50125D}"/>
+                <a16:creationId xmlns:a16="http://schemas.microsoft.com/office/drawing/2014/main" id="{EA450292-6623-4664-91EB-95478DC99597}"/>
               </a:ext>
             </a:extLst>
           </p:cNvPr>
@@ -25389,7 +25412,7 @@
           <p:cNvPr id="11" name="findings-two-body">
             <a:extLst xmlns:a="http://schemas.openxmlformats.org/drawingml/2006/main">
               <a:ext uri="{FF2B5EF4-FFF2-40B4-BE49-F238E27FC236}">
-                <a16:creationId xmlns:a16="http://schemas.microsoft.com/office/drawing/2014/main" id="{1C33D5B0-E385-4922-B91A-8D7E5162AF08}"/>
+                <a16:creationId xmlns:a16="http://schemas.microsoft.com/office/drawing/2014/main" id="{1115C6CD-C094-4E9C-82FB-FED0E979B3F6}"/>
               </a:ext>
             </a:extLst>
           </p:cNvPr>
@@ -25548,7 +25571,7 @@
           <p:cNvPr id="12" name="findings-separator-2">
             <a:extLst xmlns:a="http://schemas.openxmlformats.org/drawingml/2006/main">
               <a:ext uri="{FF2B5EF4-FFF2-40B4-BE49-F238E27FC236}">
-                <a16:creationId xmlns:a16="http://schemas.microsoft.com/office/drawing/2014/main" id="{5983C72D-4CD4-481D-8E0A-9F7B3654A4DF}"/>
+                <a16:creationId xmlns:a16="http://schemas.microsoft.com/office/drawing/2014/main" id="{EFBC6701-77FF-44E5-96AD-00DEB6ACB627}"/>
               </a:ext>
             </a:extLst>
           </p:cNvPr>
@@ -25579,7 +25602,7 @@
           <p:cNvPr id="13" name="findings-three">
             <a:extLst xmlns:a="http://schemas.openxmlformats.org/drawingml/2006/main">
               <a:ext uri="{FF2B5EF4-FFF2-40B4-BE49-F238E27FC236}">
-                <a16:creationId xmlns:a16="http://schemas.microsoft.com/office/drawing/2014/main" id="{1D5D4051-11D8-41C8-8B07-10CD51F5DC5B}"/>
+                <a16:creationId xmlns:a16="http://schemas.microsoft.com/office/drawing/2014/main" id="{6F0617B7-74F3-4E77-AB56-6E532B7ABA62}"/>
               </a:ext>
             </a:extLst>
           </p:cNvPr>
@@ -25738,7 +25761,7 @@
           <p:cNvPr id="14" name="findings-three-body">
             <a:extLst xmlns:a="http://schemas.openxmlformats.org/drawingml/2006/main">
               <a:ext uri="{FF2B5EF4-FFF2-40B4-BE49-F238E27FC236}">
-                <a16:creationId xmlns:a16="http://schemas.microsoft.com/office/drawing/2014/main" id="{CD8B9C0A-6B5B-4657-810A-65E3BE65701B}"/>
+                <a16:creationId xmlns:a16="http://schemas.microsoft.com/office/drawing/2014/main" id="{B3BF1ED3-BD4D-4760-A6D5-DCCA9E1A9218}"/>
               </a:ext>
             </a:extLst>
           </p:cNvPr>
@@ -25897,7 +25920,7 @@
           <p:cNvPr id="15" name="findings-interval">
             <a:extLst xmlns:a="http://schemas.openxmlformats.org/drawingml/2006/main">
               <a:ext uri="{FF2B5EF4-FFF2-40B4-BE49-F238E27FC236}">
-                <a16:creationId xmlns:a16="http://schemas.microsoft.com/office/drawing/2014/main" id="{80E3E5CF-F32C-4888-B2D9-0CF8CFE85214}"/>
+                <a16:creationId xmlns:a16="http://schemas.microsoft.com/office/drawing/2014/main" id="{9D10F009-488D-4412-A559-47E0E031E845}"/>
               </a:ext>
             </a:extLst>
           </p:cNvPr>
@@ -26054,7 +26077,7 @@
     </p:spTree>
     <p:extLst>
       <p:ext uri="{BB962C8B-B14F-4D97-AF65-F5344CB8AC3E}">
-        <p14:creationId xmlns:p14="http://schemas.microsoft.com/office/powerpoint/2010/main" val="830769503"/>
+        <p14:creationId xmlns:p14="http://schemas.microsoft.com/office/powerpoint/2010/main" val="1325592041"/>
       </p:ext>
     </p:extLst>
   </p:cSld>
@@ -26085,7 +26108,7 @@
           <p:cNvPr id="22" name="section-8">
             <a:extLst xmlns:a="http://schemas.openxmlformats.org/drawingml/2006/main">
               <a:ext uri="{FF2B5EF4-FFF2-40B4-BE49-F238E27FC236}">
-                <a16:creationId xmlns:a16="http://schemas.microsoft.com/office/drawing/2014/main" id="{F9811D4B-EA1B-41EB-B897-B48209614DE0}"/>
+                <a16:creationId xmlns:a16="http://schemas.microsoft.com/office/drawing/2014/main" id="{A43569CD-9446-4CCF-9DDE-74B90E830D81}"/>
               </a:ext>
             </a:extLst>
           </p:cNvPr>
@@ -26244,7 +26267,7 @@
           <p:cNvPr id="2" name="title-8">
             <a:extLst xmlns:a="http://schemas.openxmlformats.org/drawingml/2006/main">
               <a:ext uri="{FF2B5EF4-FFF2-40B4-BE49-F238E27FC236}">
-                <a16:creationId xmlns:a16="http://schemas.microsoft.com/office/drawing/2014/main" id="{20EFACEE-DB75-45A9-AB0A-4464157FFF05}"/>
+                <a16:creationId xmlns:a16="http://schemas.microsoft.com/office/drawing/2014/main" id="{CF5E03FF-E1B7-451A-B4D3-7B98F925DD54}"/>
               </a:ext>
             </a:extLst>
           </p:cNvPr>
@@ -26403,7 +26426,7 @@
           <p:cNvPr id="3" name="title-rule-8">
             <a:extLst xmlns:a="http://schemas.openxmlformats.org/drawingml/2006/main">
               <a:ext uri="{FF2B5EF4-FFF2-40B4-BE49-F238E27FC236}">
-                <a16:creationId xmlns:a16="http://schemas.microsoft.com/office/drawing/2014/main" id="{7502749B-13E4-4966-8E56-9C8EF1B008B3}"/>
+                <a16:creationId xmlns:a16="http://schemas.microsoft.com/office/drawing/2014/main" id="{A631FEC4-9BC6-4899-9B4B-68A7CE3A5556}"/>
               </a:ext>
             </a:extLst>
           </p:cNvPr>
@@ -26434,7 +26457,7 @@
           <p:cNvPr id="4" name="footer-rule-8">
             <a:extLst xmlns:a="http://schemas.openxmlformats.org/drawingml/2006/main">
               <a:ext uri="{FF2B5EF4-FFF2-40B4-BE49-F238E27FC236}">
-                <a16:creationId xmlns:a16="http://schemas.microsoft.com/office/drawing/2014/main" id="{274E8547-4579-4CBE-B6DD-A853267EA12C}"/>
+                <a16:creationId xmlns:a16="http://schemas.microsoft.com/office/drawing/2014/main" id="{66C374F5-8416-4EDD-B4F2-BD2BAA94C336}"/>
               </a:ext>
             </a:extLst>
           </p:cNvPr>
@@ -26465,7 +26488,7 @@
           <p:cNvPr id="5" name="footer-8">
             <a:extLst xmlns:a="http://schemas.openxmlformats.org/drawingml/2006/main">
               <a:ext uri="{FF2B5EF4-FFF2-40B4-BE49-F238E27FC236}">
-                <a16:creationId xmlns:a16="http://schemas.microsoft.com/office/drawing/2014/main" id="{71728469-A178-4F1A-A464-772DC25748E1}"/>
+                <a16:creationId xmlns:a16="http://schemas.microsoft.com/office/drawing/2014/main" id="{F4779849-7BC6-4808-A0A7-40BB9710D550}"/>
               </a:ext>
             </a:extLst>
           </p:cNvPr>
@@ -26624,7 +26647,7 @@
           <p:cNvPr id="6" name="page-8">
             <a:extLst xmlns:a="http://schemas.openxmlformats.org/drawingml/2006/main">
               <a:ext uri="{FF2B5EF4-FFF2-40B4-BE49-F238E27FC236}">
-                <a16:creationId xmlns:a16="http://schemas.microsoft.com/office/drawing/2014/main" id="{A538A23A-7166-4E53-BEF4-4D46E16C498D}"/>
+                <a16:creationId xmlns:a16="http://schemas.microsoft.com/office/drawing/2014/main" id="{2AD19CAD-50C4-4DFF-BE51-EB9AC2C9E241}"/>
               </a:ext>
             </a:extLst>
           </p:cNvPr>
@@ -26783,7 +26806,7 @@
           <p:cNvPr id="7" name="demo-letter-0">
             <a:extLst xmlns:a="http://schemas.openxmlformats.org/drawingml/2006/main">
               <a:ext uri="{FF2B5EF4-FFF2-40B4-BE49-F238E27FC236}">
-                <a16:creationId xmlns:a16="http://schemas.microsoft.com/office/drawing/2014/main" id="{146C33D1-B0CE-4A5A-A50F-537B0C2BCDB4}"/>
+                <a16:creationId xmlns:a16="http://schemas.microsoft.com/office/drawing/2014/main" id="{38733F70-8948-4233-96AE-CAAE03DC4C08}"/>
               </a:ext>
             </a:extLst>
           </p:cNvPr>
@@ -26942,7 +26965,7 @@
           <p:cNvPr id="8" name="demo-title-0">
             <a:extLst xmlns:a="http://schemas.openxmlformats.org/drawingml/2006/main">
               <a:ext uri="{FF2B5EF4-FFF2-40B4-BE49-F238E27FC236}">
-                <a16:creationId xmlns:a16="http://schemas.microsoft.com/office/drawing/2014/main" id="{AE3625F9-EC97-4EA3-8F9D-F5270DBA8A8E}"/>
+                <a16:creationId xmlns:a16="http://schemas.microsoft.com/office/drawing/2014/main" id="{13BD8733-1026-4A7F-9D47-02A92384D45D}"/>
               </a:ext>
             </a:extLst>
           </p:cNvPr>
@@ -27101,7 +27124,7 @@
           <p:cNvPr id="9" name="demo-detail-0">
             <a:extLst xmlns:a="http://schemas.openxmlformats.org/drawingml/2006/main">
               <a:ext uri="{FF2B5EF4-FFF2-40B4-BE49-F238E27FC236}">
-                <a16:creationId xmlns:a16="http://schemas.microsoft.com/office/drawing/2014/main" id="{0C414497-F9C3-49DF-81FC-209DF7F04564}"/>
+                <a16:creationId xmlns:a16="http://schemas.microsoft.com/office/drawing/2014/main" id="{F26EEEE0-D1A5-4CCB-B46C-CB1CB609ABEC}"/>
               </a:ext>
             </a:extLst>
           </p:cNvPr>
@@ -27260,7 +27283,7 @@
           <p:cNvPr id="10" name="demo-rule-0">
             <a:extLst xmlns:a="http://schemas.openxmlformats.org/drawingml/2006/main">
               <a:ext uri="{FF2B5EF4-FFF2-40B4-BE49-F238E27FC236}">
-                <a16:creationId xmlns:a16="http://schemas.microsoft.com/office/drawing/2014/main" id="{D8131BFF-18C2-4768-9650-9340136E22A2}"/>
+                <a16:creationId xmlns:a16="http://schemas.microsoft.com/office/drawing/2014/main" id="{7AEDEFAA-C99C-43AA-B839-C97C0967E8F5}"/>
               </a:ext>
             </a:extLst>
           </p:cNvPr>
@@ -27291,7 +27314,7 @@
           <p:cNvPr id="11" name="demo-letter-1">
             <a:extLst xmlns:a="http://schemas.openxmlformats.org/drawingml/2006/main">
               <a:ext uri="{FF2B5EF4-FFF2-40B4-BE49-F238E27FC236}">
-                <a16:creationId xmlns:a16="http://schemas.microsoft.com/office/drawing/2014/main" id="{F9D88B56-70FF-4849-8DAD-A1645F3B6323}"/>
+                <a16:creationId xmlns:a16="http://schemas.microsoft.com/office/drawing/2014/main" id="{8440FD77-3F93-46B2-AA9B-ED3B6ED1677B}"/>
               </a:ext>
             </a:extLst>
           </p:cNvPr>
@@ -27450,7 +27473,7 @@
           <p:cNvPr id="12" name="demo-title-1">
             <a:extLst xmlns:a="http://schemas.openxmlformats.org/drawingml/2006/main">
               <a:ext uri="{FF2B5EF4-FFF2-40B4-BE49-F238E27FC236}">
-                <a16:creationId xmlns:a16="http://schemas.microsoft.com/office/drawing/2014/main" id="{7A4A0C34-BAA5-4775-8CD0-78F81DC07985}"/>
+                <a16:creationId xmlns:a16="http://schemas.microsoft.com/office/drawing/2014/main" id="{058344BE-82C5-4601-B047-CD83D338E94D}"/>
               </a:ext>
             </a:extLst>
           </p:cNvPr>
@@ -27609,7 +27632,7 @@
           <p:cNvPr id="13" name="demo-detail-1">
             <a:extLst xmlns:a="http://schemas.openxmlformats.org/drawingml/2006/main">
               <a:ext uri="{FF2B5EF4-FFF2-40B4-BE49-F238E27FC236}">
-                <a16:creationId xmlns:a16="http://schemas.microsoft.com/office/drawing/2014/main" id="{5D71D372-95D1-4FEF-955A-DE15A334FBD6}"/>
+                <a16:creationId xmlns:a16="http://schemas.microsoft.com/office/drawing/2014/main" id="{77E68F21-04C9-4B11-9436-B03E899A6F82}"/>
               </a:ext>
             </a:extLst>
           </p:cNvPr>
@@ -27768,7 +27791,7 @@
           <p:cNvPr id="14" name="demo-rule-1">
             <a:extLst xmlns:a="http://schemas.openxmlformats.org/drawingml/2006/main">
               <a:ext uri="{FF2B5EF4-FFF2-40B4-BE49-F238E27FC236}">
-                <a16:creationId xmlns:a16="http://schemas.microsoft.com/office/drawing/2014/main" id="{56891BE1-65F1-4961-A5FC-85806E525503}"/>
+                <a16:creationId xmlns:a16="http://schemas.microsoft.com/office/drawing/2014/main" id="{D162BA64-5FD2-4E74-8EB9-17C39FF65050}"/>
               </a:ext>
             </a:extLst>
           </p:cNvPr>
@@ -27799,7 +27822,7 @@
           <p:cNvPr id="15" name="demo-letter-2">
             <a:extLst xmlns:a="http://schemas.openxmlformats.org/drawingml/2006/main">
               <a:ext uri="{FF2B5EF4-FFF2-40B4-BE49-F238E27FC236}">
-                <a16:creationId xmlns:a16="http://schemas.microsoft.com/office/drawing/2014/main" id="{4692474B-3946-495A-9CA0-24A6DB0425CA}"/>
+                <a16:creationId xmlns:a16="http://schemas.microsoft.com/office/drawing/2014/main" id="{0DCE99D4-E2B8-43F1-B877-EE80A7208361}"/>
               </a:ext>
             </a:extLst>
           </p:cNvPr>
@@ -27958,7 +27981,7 @@
           <p:cNvPr id="16" name="demo-title-2">
             <a:extLst xmlns:a="http://schemas.openxmlformats.org/drawingml/2006/main">
               <a:ext uri="{FF2B5EF4-FFF2-40B4-BE49-F238E27FC236}">
-                <a16:creationId xmlns:a16="http://schemas.microsoft.com/office/drawing/2014/main" id="{26D32C5C-56C5-449A-A248-B5B5F153614F}"/>
+                <a16:creationId xmlns:a16="http://schemas.microsoft.com/office/drawing/2014/main" id="{08313A1B-436A-4033-9B18-C69B41141652}"/>
               </a:ext>
             </a:extLst>
           </p:cNvPr>
@@ -28117,7 +28140,7 @@
           <p:cNvPr id="17" name="demo-detail-2">
             <a:extLst xmlns:a="http://schemas.openxmlformats.org/drawingml/2006/main">
               <a:ext uri="{FF2B5EF4-FFF2-40B4-BE49-F238E27FC236}">
-                <a16:creationId xmlns:a16="http://schemas.microsoft.com/office/drawing/2014/main" id="{2F61071D-94FF-42A3-AE64-B2DDA7CFD89E}"/>
+                <a16:creationId xmlns:a16="http://schemas.microsoft.com/office/drawing/2014/main" id="{E5482427-0F20-4BB3-B946-B8DC95CE93AE}"/>
               </a:ext>
             </a:extLst>
           </p:cNvPr>
@@ -28276,7 +28299,7 @@
           <p:cNvPr id="18" name="demo-rule-2">
             <a:extLst xmlns:a="http://schemas.openxmlformats.org/drawingml/2006/main">
               <a:ext uri="{FF2B5EF4-FFF2-40B4-BE49-F238E27FC236}">
-                <a16:creationId xmlns:a16="http://schemas.microsoft.com/office/drawing/2014/main" id="{78D198B3-F965-4A09-968A-304653AC0F9B}"/>
+                <a16:creationId xmlns:a16="http://schemas.microsoft.com/office/drawing/2014/main" id="{3A759184-86AC-45D4-B4D5-65433C46CD7E}"/>
               </a:ext>
             </a:extLst>
           </p:cNvPr>
@@ -28307,7 +28330,7 @@
           <p:cNvPr id="19" name="demo-letter-3">
             <a:extLst xmlns:a="http://schemas.openxmlformats.org/drawingml/2006/main">
               <a:ext uri="{FF2B5EF4-FFF2-40B4-BE49-F238E27FC236}">
-                <a16:creationId xmlns:a16="http://schemas.microsoft.com/office/drawing/2014/main" id="{EB6E97C3-DFF4-41F0-9A79-C52B904461F1}"/>
+                <a16:creationId xmlns:a16="http://schemas.microsoft.com/office/drawing/2014/main" id="{37B85AFA-2BCD-4E89-BBBF-72B82F87DAA6}"/>
               </a:ext>
             </a:extLst>
           </p:cNvPr>
@@ -28466,7 +28489,7 @@
           <p:cNvPr id="20" name="demo-title-3">
             <a:extLst xmlns:a="http://schemas.openxmlformats.org/drawingml/2006/main">
               <a:ext uri="{FF2B5EF4-FFF2-40B4-BE49-F238E27FC236}">
-                <a16:creationId xmlns:a16="http://schemas.microsoft.com/office/drawing/2014/main" id="{B590DA7F-7134-4F2A-AB71-C3A22507486F}"/>
+                <a16:creationId xmlns:a16="http://schemas.microsoft.com/office/drawing/2014/main" id="{DEF15FC7-06F0-4D4F-AA3D-6B0B779868A5}"/>
               </a:ext>
             </a:extLst>
           </p:cNvPr>
@@ -28625,7 +28648,7 @@
           <p:cNvPr id="21" name="demo-detail-3">
             <a:extLst xmlns:a="http://schemas.openxmlformats.org/drawingml/2006/main">
               <a:ext uri="{FF2B5EF4-FFF2-40B4-BE49-F238E27FC236}">
-                <a16:creationId xmlns:a16="http://schemas.microsoft.com/office/drawing/2014/main" id="{47E453C2-B721-4890-8647-3E77803E30D2}"/>
+                <a16:creationId xmlns:a16="http://schemas.microsoft.com/office/drawing/2014/main" id="{61F3E228-6D56-4629-A1B8-B7E561398395}"/>
               </a:ext>
             </a:extLst>
           </p:cNvPr>
@@ -28782,7 +28805,7 @@
     </p:spTree>
     <p:extLst>
       <p:ext uri="{BB962C8B-B14F-4D97-AF65-F5344CB8AC3E}">
-        <p14:creationId xmlns:p14="http://schemas.microsoft.com/office/powerpoint/2010/main" val="898922589"/>
+        <p14:creationId xmlns:p14="http://schemas.microsoft.com/office/powerpoint/2010/main" val="1101691288"/>
       </p:ext>
     </p:extLst>
   </p:cSld>
@@ -28813,7 +28836,7 @@
           <p:cNvPr id="16" name="section-9">
             <a:extLst xmlns:a="http://schemas.openxmlformats.org/drawingml/2006/main">
               <a:ext uri="{FF2B5EF4-FFF2-40B4-BE49-F238E27FC236}">
-                <a16:creationId xmlns:a16="http://schemas.microsoft.com/office/drawing/2014/main" id="{53D86AD7-5DD8-4B4C-B876-265F32CD88EC}"/>
+                <a16:creationId xmlns:a16="http://schemas.microsoft.com/office/drawing/2014/main" id="{7157224F-A7DB-434E-8826-C92EDA94380E}"/>
               </a:ext>
             </a:extLst>
           </p:cNvPr>
@@ -28972,7 +28995,7 @@
           <p:cNvPr id="2" name="title-9">
             <a:extLst xmlns:a="http://schemas.openxmlformats.org/drawingml/2006/main">
               <a:ext uri="{FF2B5EF4-FFF2-40B4-BE49-F238E27FC236}">
-                <a16:creationId xmlns:a16="http://schemas.microsoft.com/office/drawing/2014/main" id="{26CE7BEF-CFA9-47E4-A0ED-93D73311762E}"/>
+                <a16:creationId xmlns:a16="http://schemas.microsoft.com/office/drawing/2014/main" id="{A10CACEE-7FDF-47A7-BC9D-8FAE33F4B039}"/>
               </a:ext>
             </a:extLst>
           </p:cNvPr>
@@ -29131,7 +29154,7 @@
           <p:cNvPr id="3" name="title-rule-9">
             <a:extLst xmlns:a="http://schemas.openxmlformats.org/drawingml/2006/main">
               <a:ext uri="{FF2B5EF4-FFF2-40B4-BE49-F238E27FC236}">
-                <a16:creationId xmlns:a16="http://schemas.microsoft.com/office/drawing/2014/main" id="{DB8FDC30-604E-460C-A8DA-1808F5991C0E}"/>
+                <a16:creationId xmlns:a16="http://schemas.microsoft.com/office/drawing/2014/main" id="{083FC9C3-CB5E-49F2-AA4B-1545A294F1E5}"/>
               </a:ext>
             </a:extLst>
           </p:cNvPr>
@@ -29162,7 +29185,7 @@
           <p:cNvPr id="4" name="footer-rule-9">
             <a:extLst xmlns:a="http://schemas.openxmlformats.org/drawingml/2006/main">
               <a:ext uri="{FF2B5EF4-FFF2-40B4-BE49-F238E27FC236}">
-                <a16:creationId xmlns:a16="http://schemas.microsoft.com/office/drawing/2014/main" id="{380B41B1-072F-40B2-9642-D8E7E86D9EAD}"/>
+                <a16:creationId xmlns:a16="http://schemas.microsoft.com/office/drawing/2014/main" id="{1881F48F-452C-4AB7-9421-510A4C5C0A25}"/>
               </a:ext>
             </a:extLst>
           </p:cNvPr>
@@ -29193,7 +29216,7 @@
           <p:cNvPr id="5" name="footer-9">
             <a:extLst xmlns:a="http://schemas.openxmlformats.org/drawingml/2006/main">
               <a:ext uri="{FF2B5EF4-FFF2-40B4-BE49-F238E27FC236}">
-                <a16:creationId xmlns:a16="http://schemas.microsoft.com/office/drawing/2014/main" id="{FB94DD4B-F493-4EF4-B4CD-F604864F8C8C}"/>
+                <a16:creationId xmlns:a16="http://schemas.microsoft.com/office/drawing/2014/main" id="{4593E6D5-70FE-4240-9626-B39E1E58C905}"/>
               </a:ext>
             </a:extLst>
           </p:cNvPr>
@@ -29352,7 +29375,7 @@
           <p:cNvPr id="6" name="page-9">
             <a:extLst xmlns:a="http://schemas.openxmlformats.org/drawingml/2006/main">
               <a:ext uri="{FF2B5EF4-FFF2-40B4-BE49-F238E27FC236}">
-                <a16:creationId xmlns:a16="http://schemas.microsoft.com/office/drawing/2014/main" id="{CD34DF96-9C03-406B-A934-510C85255910}"/>
+                <a16:creationId xmlns:a16="http://schemas.microsoft.com/office/drawing/2014/main" id="{1FBF8645-A559-43C6-AA42-3115CCAB34BC}"/>
               </a:ext>
             </a:extLst>
           </p:cNvPr>
@@ -29511,7 +29534,7 @@
           <p:cNvPr id="7" name="deploy-entry">
             <a:extLst xmlns:a="http://schemas.openxmlformats.org/drawingml/2006/main">
               <a:ext uri="{FF2B5EF4-FFF2-40B4-BE49-F238E27FC236}">
-                <a16:creationId xmlns:a16="http://schemas.microsoft.com/office/drawing/2014/main" id="{A902F1E4-7319-4C09-A05F-B6ADB9E2952F}"/>
+                <a16:creationId xmlns:a16="http://schemas.microsoft.com/office/drawing/2014/main" id="{A37B6CB6-B1C1-4FD6-A210-80A796DCEA2B}"/>
               </a:ext>
             </a:extLst>
           </p:cNvPr>
@@ -29670,7 +29693,7 @@
           <p:cNvPr id="8" name="deploy-entry-body">
             <a:extLst xmlns:a="http://schemas.openxmlformats.org/drawingml/2006/main">
               <a:ext uri="{FF2B5EF4-FFF2-40B4-BE49-F238E27FC236}">
-                <a16:creationId xmlns:a16="http://schemas.microsoft.com/office/drawing/2014/main" id="{28F671BA-2B0A-482F-BE1E-631FA5338E86}"/>
+                <a16:creationId xmlns:a16="http://schemas.microsoft.com/office/drawing/2014/main" id="{08DA4E5E-359E-4602-AF30-E33AEADA4038}"/>
               </a:ext>
             </a:extLst>
           </p:cNvPr>
@@ -29875,7 +29898,7 @@
           <p:cNvPr id="9" name="deploy-divider-1">
             <a:extLst xmlns:a="http://schemas.openxmlformats.org/drawingml/2006/main">
               <a:ext uri="{FF2B5EF4-FFF2-40B4-BE49-F238E27FC236}">
-                <a16:creationId xmlns:a16="http://schemas.microsoft.com/office/drawing/2014/main" id="{5AD87B8E-8A77-471D-8DDA-348F3D1426CF}"/>
+                <a16:creationId xmlns:a16="http://schemas.microsoft.com/office/drawing/2014/main" id="{D32520C7-532C-451F-8B8E-71E49A7D8BDB}"/>
               </a:ext>
             </a:extLst>
           </p:cNvPr>
@@ -29906,7 +29929,7 @@
           <p:cNvPr id="10" name="deploy-state">
             <a:extLst xmlns:a="http://schemas.openxmlformats.org/drawingml/2006/main">
               <a:ext uri="{FF2B5EF4-FFF2-40B4-BE49-F238E27FC236}">
-                <a16:creationId xmlns:a16="http://schemas.microsoft.com/office/drawing/2014/main" id="{51C3E963-6E96-44EB-9339-3BBCB66C8243}"/>
+                <a16:creationId xmlns:a16="http://schemas.microsoft.com/office/drawing/2014/main" id="{0C38F6FD-1589-4D64-B511-E2F12888ADC4}"/>
               </a:ext>
             </a:extLst>
           </p:cNvPr>
@@ -30065,7 +30088,7 @@
           <p:cNvPr id="11" name="deploy-state-body">
             <a:extLst xmlns:a="http://schemas.openxmlformats.org/drawingml/2006/main">
               <a:ext uri="{FF2B5EF4-FFF2-40B4-BE49-F238E27FC236}">
-                <a16:creationId xmlns:a16="http://schemas.microsoft.com/office/drawing/2014/main" id="{6C394E3B-26AD-4242-813C-D856BEDCAC49}"/>
+                <a16:creationId xmlns:a16="http://schemas.microsoft.com/office/drawing/2014/main" id="{4D89513F-5285-4B36-990C-269860B7602F}"/>
               </a:ext>
             </a:extLst>
           </p:cNvPr>
@@ -30270,7 +30293,7 @@
           <p:cNvPr id="12" name="deploy-divider-2">
             <a:extLst xmlns:a="http://schemas.openxmlformats.org/drawingml/2006/main">
               <a:ext uri="{FF2B5EF4-FFF2-40B4-BE49-F238E27FC236}">
-                <a16:creationId xmlns:a16="http://schemas.microsoft.com/office/drawing/2014/main" id="{0E4C3BE9-F81A-46C7-ADB0-B77EC17005BF}"/>
+                <a16:creationId xmlns:a16="http://schemas.microsoft.com/office/drawing/2014/main" id="{CEBD7FDD-7028-4539-B570-9399F94FF874}"/>
               </a:ext>
             </a:extLst>
           </p:cNvPr>
@@ -30301,7 +30324,7 @@
           <p:cNvPr id="13" name="deploy-secret">
             <a:extLst xmlns:a="http://schemas.openxmlformats.org/drawingml/2006/main">
               <a:ext uri="{FF2B5EF4-FFF2-40B4-BE49-F238E27FC236}">
-                <a16:creationId xmlns:a16="http://schemas.microsoft.com/office/drawing/2014/main" id="{1238ABF8-284C-4F7F-9E9E-0C9D5116CB32}"/>
+                <a16:creationId xmlns:a16="http://schemas.microsoft.com/office/drawing/2014/main" id="{AD39F4BA-2D60-4BEB-BDBD-743ACF7E0A67}"/>
               </a:ext>
             </a:extLst>
           </p:cNvPr>
@@ -30460,7 +30483,7 @@
           <p:cNvPr id="14" name="deploy-secret-body">
             <a:extLst xmlns:a="http://schemas.openxmlformats.org/drawingml/2006/main">
               <a:ext uri="{FF2B5EF4-FFF2-40B4-BE49-F238E27FC236}">
-                <a16:creationId xmlns:a16="http://schemas.microsoft.com/office/drawing/2014/main" id="{83A5BFE6-361D-4BDB-871C-9C15C811FBF1}"/>
+                <a16:creationId xmlns:a16="http://schemas.microsoft.com/office/drawing/2014/main" id="{37593796-9103-4BE9-BBAE-21785380797C}"/>
               </a:ext>
             </a:extLst>
           </p:cNvPr>
@@ -30665,7 +30688,7 @@
           <p:cNvPr id="15" name="deploy-safety">
             <a:extLst xmlns:a="http://schemas.openxmlformats.org/drawingml/2006/main">
               <a:ext uri="{FF2B5EF4-FFF2-40B4-BE49-F238E27FC236}">
-                <a16:creationId xmlns:a16="http://schemas.microsoft.com/office/drawing/2014/main" id="{422211FE-8231-47DD-B805-43C0D953E4ED}"/>
+                <a16:creationId xmlns:a16="http://schemas.microsoft.com/office/drawing/2014/main" id="{29B51D24-45C2-4765-A269-FCCAAB827E3C}"/>
               </a:ext>
             </a:extLst>
           </p:cNvPr>
@@ -30822,7 +30845,7 @@
     </p:spTree>
     <p:extLst>
       <p:ext uri="{BB962C8B-B14F-4D97-AF65-F5344CB8AC3E}">
-        <p14:creationId xmlns:p14="http://schemas.microsoft.com/office/powerpoint/2010/main" val="581102669"/>
+        <p14:creationId xmlns:p14="http://schemas.microsoft.com/office/powerpoint/2010/main" val="142886668"/>
       </p:ext>
     </p:extLst>
   </p:cSld>

</xml_diff>